<commit_message>
Auto push at 08:18:41
</commit_message>
<xml_diff>
--- a/Semester 7/algorithm engineering/slides (murad sir)/3.pptx
+++ b/Semester 7/algorithm engineering/slides (murad sir)/3.pptx
@@ -18,7 +18,13 @@
     <p:sldId id="260" r:id="rId12"/>
     <p:sldId id="261" r:id="rId13"/>
     <p:sldId id="262" r:id="rId14"/>
-    <p:sldId id="263" r:id="rId15"/>
+    <p:sldId id="272" r:id="rId15"/>
+    <p:sldId id="271" r:id="rId16"/>
+    <p:sldId id="263" r:id="rId17"/>
+    <p:sldId id="273" r:id="rId18"/>
+    <p:sldId id="274" r:id="rId19"/>
+    <p:sldId id="275" r:id="rId20"/>
+    <p:sldId id="276" r:id="rId21"/>
   </p:sldIdLst>
   <p:sldSz cx="12192000" cy="6858000"/>
   <p:notesSz cx="6858000" cy="9144000"/>
@@ -119,7 +125,7 @@
   </p:defaultTextStyle>
   <p:extLst>
     <p:ext uri="{EFAFB233-063F-42B5-8137-9DF3F51BA10A}">
-      <p15:sldGuideLst xmlns="" xmlns:p15="http://schemas.microsoft.com/office/powerpoint/2012/main">
+      <p15:sldGuideLst xmlns:p15="http://schemas.microsoft.com/office/powerpoint/2012/main">
         <p15:guide id="1" orient="horz" pos="2160">
           <p15:clr>
             <a:srgbClr val="A4A3A4"/>
@@ -178,10 +184,9 @@
           </a:lstStyle>
           <a:p>
             <a:r>
-              <a:rPr lang="en-US" smtClean="0"/>
+              <a:rPr lang="en-US"/>
               <a:t>Click to edit Master title style</a:t>
             </a:r>
-            <a:endParaRPr lang="en-US"/>
           </a:p>
         </p:txBody>
       </p:sp>
@@ -243,10 +248,9 @@
           </a:lstStyle>
           <a:p>
             <a:r>
-              <a:rPr lang="en-US" smtClean="0"/>
+              <a:rPr lang="en-US"/>
               <a:t>Click to edit Master subtitle style</a:t>
             </a:r>
-            <a:endParaRPr lang="en-US"/>
           </a:p>
         </p:txBody>
       </p:sp>
@@ -268,7 +272,7 @@
             <a:fld id="{4FB35DA8-B7CA-4C53-9105-91D1C2AF5D9E}" type="datetimeFigureOut">
               <a:rPr lang="en-US" smtClean="0"/>
               <a:pPr/>
-              <a:t>21-Jul-26</a:t>
+              <a:t>7/22/2026</a:t>
             </a:fld>
             <a:endParaRPr lang="en-US"/>
           </a:p>
@@ -320,7 +324,7 @@
     </p:spTree>
     <p:extLst>
       <p:ext uri="{BB962C8B-B14F-4D97-AF65-F5344CB8AC3E}">
-        <p14:creationId xmlns="" xmlns:p14="http://schemas.microsoft.com/office/powerpoint/2010/main" val="128161764"/>
+        <p14:creationId xmlns:p14="http://schemas.microsoft.com/office/powerpoint/2010/main" val="128161764"/>
       </p:ext>
     </p:extLst>
   </p:cSld>
@@ -363,10 +367,9 @@
           <a:lstStyle/>
           <a:p>
             <a:r>
-              <a:rPr lang="en-US" smtClean="0"/>
+              <a:rPr lang="en-US"/>
               <a:t>Click to edit Master title style</a:t>
             </a:r>
-            <a:endParaRPr lang="en-US"/>
           </a:p>
         </p:txBody>
       </p:sp>
@@ -387,38 +390,37 @@
           <a:p>
             <a:pPr lvl="0"/>
             <a:r>
-              <a:rPr lang="en-US" smtClean="0"/>
+              <a:rPr lang="en-US"/>
               <a:t>Click to edit Master text styles</a:t>
             </a:r>
           </a:p>
           <a:p>
             <a:pPr lvl="1"/>
             <a:r>
-              <a:rPr lang="en-US" smtClean="0"/>
+              <a:rPr lang="en-US"/>
               <a:t>Second level</a:t>
             </a:r>
           </a:p>
           <a:p>
             <a:pPr lvl="2"/>
             <a:r>
-              <a:rPr lang="en-US" smtClean="0"/>
+              <a:rPr lang="en-US"/>
               <a:t>Third level</a:t>
             </a:r>
           </a:p>
           <a:p>
             <a:pPr lvl="3"/>
             <a:r>
-              <a:rPr lang="en-US" smtClean="0"/>
+              <a:rPr lang="en-US"/>
               <a:t>Fourth level</a:t>
             </a:r>
           </a:p>
           <a:p>
             <a:pPr lvl="4"/>
             <a:r>
-              <a:rPr lang="en-US" smtClean="0"/>
+              <a:rPr lang="en-US"/>
               <a:t>Fifth level</a:t>
             </a:r>
-            <a:endParaRPr lang="en-US"/>
           </a:p>
         </p:txBody>
       </p:sp>
@@ -440,7 +442,7 @@
             <a:fld id="{4FB35DA8-B7CA-4C53-9105-91D1C2AF5D9E}" type="datetimeFigureOut">
               <a:rPr lang="en-US" smtClean="0"/>
               <a:pPr/>
-              <a:t>21-Jul-26</a:t>
+              <a:t>7/22/2026</a:t>
             </a:fld>
             <a:endParaRPr lang="en-US"/>
           </a:p>
@@ -492,7 +494,7 @@
     </p:spTree>
     <p:extLst>
       <p:ext uri="{BB962C8B-B14F-4D97-AF65-F5344CB8AC3E}">
-        <p14:creationId xmlns="" xmlns:p14="http://schemas.microsoft.com/office/powerpoint/2010/main" val="3197726211"/>
+        <p14:creationId xmlns:p14="http://schemas.microsoft.com/office/powerpoint/2010/main" val="3197726211"/>
       </p:ext>
     </p:extLst>
   </p:cSld>
@@ -540,10 +542,9 @@
           <a:lstStyle/>
           <a:p>
             <a:r>
-              <a:rPr lang="en-US" smtClean="0"/>
+              <a:rPr lang="en-US"/>
               <a:t>Click to edit Master title style</a:t>
             </a:r>
-            <a:endParaRPr lang="en-US"/>
           </a:p>
         </p:txBody>
       </p:sp>
@@ -569,38 +570,37 @@
           <a:p>
             <a:pPr lvl="0"/>
             <a:r>
-              <a:rPr lang="en-US" smtClean="0"/>
+              <a:rPr lang="en-US"/>
               <a:t>Click to edit Master text styles</a:t>
             </a:r>
           </a:p>
           <a:p>
             <a:pPr lvl="1"/>
             <a:r>
-              <a:rPr lang="en-US" smtClean="0"/>
+              <a:rPr lang="en-US"/>
               <a:t>Second level</a:t>
             </a:r>
           </a:p>
           <a:p>
             <a:pPr lvl="2"/>
             <a:r>
-              <a:rPr lang="en-US" smtClean="0"/>
+              <a:rPr lang="en-US"/>
               <a:t>Third level</a:t>
             </a:r>
           </a:p>
           <a:p>
             <a:pPr lvl="3"/>
             <a:r>
-              <a:rPr lang="en-US" smtClean="0"/>
+              <a:rPr lang="en-US"/>
               <a:t>Fourth level</a:t>
             </a:r>
           </a:p>
           <a:p>
             <a:pPr lvl="4"/>
             <a:r>
-              <a:rPr lang="en-US" smtClean="0"/>
+              <a:rPr lang="en-US"/>
               <a:t>Fifth level</a:t>
             </a:r>
-            <a:endParaRPr lang="en-US"/>
           </a:p>
         </p:txBody>
       </p:sp>
@@ -622,7 +622,7 @@
             <a:fld id="{4FB35DA8-B7CA-4C53-9105-91D1C2AF5D9E}" type="datetimeFigureOut">
               <a:rPr lang="en-US" smtClean="0"/>
               <a:pPr/>
-              <a:t>21-Jul-26</a:t>
+              <a:t>7/22/2026</a:t>
             </a:fld>
             <a:endParaRPr lang="en-US"/>
           </a:p>
@@ -674,7 +674,7 @@
     </p:spTree>
     <p:extLst>
       <p:ext uri="{BB962C8B-B14F-4D97-AF65-F5344CB8AC3E}">
-        <p14:creationId xmlns="" xmlns:p14="http://schemas.microsoft.com/office/powerpoint/2010/main" val="461519305"/>
+        <p14:creationId xmlns:p14="http://schemas.microsoft.com/office/powerpoint/2010/main" val="461519305"/>
       </p:ext>
     </p:extLst>
   </p:cSld>
@@ -717,10 +717,9 @@
           <a:lstStyle/>
           <a:p>
             <a:r>
-              <a:rPr lang="en-US" smtClean="0"/>
+              <a:rPr lang="en-US"/>
               <a:t>Click to edit Master title style</a:t>
             </a:r>
-            <a:endParaRPr lang="en-US"/>
           </a:p>
         </p:txBody>
       </p:sp>
@@ -741,38 +740,37 @@
           <a:p>
             <a:pPr lvl="0"/>
             <a:r>
-              <a:rPr lang="en-US" smtClean="0"/>
+              <a:rPr lang="en-US"/>
               <a:t>Click to edit Master text styles</a:t>
             </a:r>
           </a:p>
           <a:p>
             <a:pPr lvl="1"/>
             <a:r>
-              <a:rPr lang="en-US" smtClean="0"/>
+              <a:rPr lang="en-US"/>
               <a:t>Second level</a:t>
             </a:r>
           </a:p>
           <a:p>
             <a:pPr lvl="2"/>
             <a:r>
-              <a:rPr lang="en-US" smtClean="0"/>
+              <a:rPr lang="en-US"/>
               <a:t>Third level</a:t>
             </a:r>
           </a:p>
           <a:p>
             <a:pPr lvl="3"/>
             <a:r>
-              <a:rPr lang="en-US" smtClean="0"/>
+              <a:rPr lang="en-US"/>
               <a:t>Fourth level</a:t>
             </a:r>
           </a:p>
           <a:p>
             <a:pPr lvl="4"/>
             <a:r>
-              <a:rPr lang="en-US" smtClean="0"/>
+              <a:rPr lang="en-US"/>
               <a:t>Fifth level</a:t>
             </a:r>
-            <a:endParaRPr lang="en-US"/>
           </a:p>
         </p:txBody>
       </p:sp>
@@ -794,7 +792,7 @@
             <a:fld id="{4FB35DA8-B7CA-4C53-9105-91D1C2AF5D9E}" type="datetimeFigureOut">
               <a:rPr lang="en-US" smtClean="0"/>
               <a:pPr/>
-              <a:t>21-Jul-26</a:t>
+              <a:t>7/22/2026</a:t>
             </a:fld>
             <a:endParaRPr lang="en-US"/>
           </a:p>
@@ -846,7 +844,7 @@
     </p:spTree>
     <p:extLst>
       <p:ext uri="{BB962C8B-B14F-4D97-AF65-F5344CB8AC3E}">
-        <p14:creationId xmlns="" xmlns:p14="http://schemas.microsoft.com/office/powerpoint/2010/main" val="1097161682"/>
+        <p14:creationId xmlns:p14="http://schemas.microsoft.com/office/powerpoint/2010/main" val="1097161682"/>
       </p:ext>
     </p:extLst>
   </p:cSld>
@@ -898,10 +896,9 @@
           </a:lstStyle>
           <a:p>
             <a:r>
-              <a:rPr lang="en-US" smtClean="0"/>
+              <a:rPr lang="en-US"/>
               <a:t>Click to edit Master title style</a:t>
             </a:r>
-            <a:endParaRPr lang="en-US"/>
           </a:p>
         </p:txBody>
       </p:sp>
@@ -1018,7 +1015,7 @@
           <a:p>
             <a:pPr lvl="0"/>
             <a:r>
-              <a:rPr lang="en-US" smtClean="0"/>
+              <a:rPr lang="en-US"/>
               <a:t>Click to edit Master text styles</a:t>
             </a:r>
           </a:p>
@@ -1042,7 +1039,7 @@
             <a:fld id="{4FB35DA8-B7CA-4C53-9105-91D1C2AF5D9E}" type="datetimeFigureOut">
               <a:rPr lang="en-US" smtClean="0"/>
               <a:pPr/>
-              <a:t>21-Jul-26</a:t>
+              <a:t>7/22/2026</a:t>
             </a:fld>
             <a:endParaRPr lang="en-US"/>
           </a:p>
@@ -1094,7 +1091,7 @@
     </p:spTree>
     <p:extLst>
       <p:ext uri="{BB962C8B-B14F-4D97-AF65-F5344CB8AC3E}">
-        <p14:creationId xmlns="" xmlns:p14="http://schemas.microsoft.com/office/powerpoint/2010/main" val="2846630234"/>
+        <p14:creationId xmlns:p14="http://schemas.microsoft.com/office/powerpoint/2010/main" val="2846630234"/>
       </p:ext>
     </p:extLst>
   </p:cSld>
@@ -1137,10 +1134,9 @@
           <a:lstStyle/>
           <a:p>
             <a:r>
-              <a:rPr lang="en-US" smtClean="0"/>
+              <a:rPr lang="en-US"/>
               <a:t>Click to edit Master title style</a:t>
             </a:r>
-            <a:endParaRPr lang="en-US"/>
           </a:p>
         </p:txBody>
       </p:sp>
@@ -1166,38 +1162,37 @@
           <a:p>
             <a:pPr lvl="0"/>
             <a:r>
-              <a:rPr lang="en-US" smtClean="0"/>
+              <a:rPr lang="en-US"/>
               <a:t>Click to edit Master text styles</a:t>
             </a:r>
           </a:p>
           <a:p>
             <a:pPr lvl="1"/>
             <a:r>
-              <a:rPr lang="en-US" smtClean="0"/>
+              <a:rPr lang="en-US"/>
               <a:t>Second level</a:t>
             </a:r>
           </a:p>
           <a:p>
             <a:pPr lvl="2"/>
             <a:r>
-              <a:rPr lang="en-US" smtClean="0"/>
+              <a:rPr lang="en-US"/>
               <a:t>Third level</a:t>
             </a:r>
           </a:p>
           <a:p>
             <a:pPr lvl="3"/>
             <a:r>
-              <a:rPr lang="en-US" smtClean="0"/>
+              <a:rPr lang="en-US"/>
               <a:t>Fourth level</a:t>
             </a:r>
           </a:p>
           <a:p>
             <a:pPr lvl="4"/>
             <a:r>
-              <a:rPr lang="en-US" smtClean="0"/>
+              <a:rPr lang="en-US"/>
               <a:t>Fifth level</a:t>
             </a:r>
-            <a:endParaRPr lang="en-US"/>
           </a:p>
         </p:txBody>
       </p:sp>
@@ -1223,38 +1218,37 @@
           <a:p>
             <a:pPr lvl="0"/>
             <a:r>
-              <a:rPr lang="en-US" smtClean="0"/>
+              <a:rPr lang="en-US"/>
               <a:t>Click to edit Master text styles</a:t>
             </a:r>
           </a:p>
           <a:p>
             <a:pPr lvl="1"/>
             <a:r>
-              <a:rPr lang="en-US" smtClean="0"/>
+              <a:rPr lang="en-US"/>
               <a:t>Second level</a:t>
             </a:r>
           </a:p>
           <a:p>
             <a:pPr lvl="2"/>
             <a:r>
-              <a:rPr lang="en-US" smtClean="0"/>
+              <a:rPr lang="en-US"/>
               <a:t>Third level</a:t>
             </a:r>
           </a:p>
           <a:p>
             <a:pPr lvl="3"/>
             <a:r>
-              <a:rPr lang="en-US" smtClean="0"/>
+              <a:rPr lang="en-US"/>
               <a:t>Fourth level</a:t>
             </a:r>
           </a:p>
           <a:p>
             <a:pPr lvl="4"/>
             <a:r>
-              <a:rPr lang="en-US" smtClean="0"/>
+              <a:rPr lang="en-US"/>
               <a:t>Fifth level</a:t>
             </a:r>
-            <a:endParaRPr lang="en-US"/>
           </a:p>
         </p:txBody>
       </p:sp>
@@ -1276,7 +1270,7 @@
             <a:fld id="{4FB35DA8-B7CA-4C53-9105-91D1C2AF5D9E}" type="datetimeFigureOut">
               <a:rPr lang="en-US" smtClean="0"/>
               <a:pPr/>
-              <a:t>21-Jul-26</a:t>
+              <a:t>7/22/2026</a:t>
             </a:fld>
             <a:endParaRPr lang="en-US"/>
           </a:p>
@@ -1328,7 +1322,7 @@
     </p:spTree>
     <p:extLst>
       <p:ext uri="{BB962C8B-B14F-4D97-AF65-F5344CB8AC3E}">
-        <p14:creationId xmlns="" xmlns:p14="http://schemas.microsoft.com/office/powerpoint/2010/main" val="3382686764"/>
+        <p14:creationId xmlns:p14="http://schemas.microsoft.com/office/powerpoint/2010/main" val="3382686764"/>
       </p:ext>
     </p:extLst>
   </p:cSld>
@@ -1376,10 +1370,9 @@
           <a:lstStyle/>
           <a:p>
             <a:r>
-              <a:rPr lang="en-US" smtClean="0"/>
+              <a:rPr lang="en-US"/>
               <a:t>Click to edit Master title style</a:t>
             </a:r>
-            <a:endParaRPr lang="en-US"/>
           </a:p>
         </p:txBody>
       </p:sp>
@@ -1442,7 +1435,7 @@
           <a:p>
             <a:pPr lvl="0"/>
             <a:r>
-              <a:rPr lang="en-US" smtClean="0"/>
+              <a:rPr lang="en-US"/>
               <a:t>Click to edit Master text styles</a:t>
             </a:r>
           </a:p>
@@ -1470,38 +1463,37 @@
           <a:p>
             <a:pPr lvl="0"/>
             <a:r>
-              <a:rPr lang="en-US" smtClean="0"/>
+              <a:rPr lang="en-US"/>
               <a:t>Click to edit Master text styles</a:t>
             </a:r>
           </a:p>
           <a:p>
             <a:pPr lvl="1"/>
             <a:r>
-              <a:rPr lang="en-US" smtClean="0"/>
+              <a:rPr lang="en-US"/>
               <a:t>Second level</a:t>
             </a:r>
           </a:p>
           <a:p>
             <a:pPr lvl="2"/>
             <a:r>
-              <a:rPr lang="en-US" smtClean="0"/>
+              <a:rPr lang="en-US"/>
               <a:t>Third level</a:t>
             </a:r>
           </a:p>
           <a:p>
             <a:pPr lvl="3"/>
             <a:r>
-              <a:rPr lang="en-US" smtClean="0"/>
+              <a:rPr lang="en-US"/>
               <a:t>Fourth level</a:t>
             </a:r>
           </a:p>
           <a:p>
             <a:pPr lvl="4"/>
             <a:r>
-              <a:rPr lang="en-US" smtClean="0"/>
+              <a:rPr lang="en-US"/>
               <a:t>Fifth level</a:t>
             </a:r>
-            <a:endParaRPr lang="en-US"/>
           </a:p>
         </p:txBody>
       </p:sp>
@@ -1564,7 +1556,7 @@
           <a:p>
             <a:pPr lvl="0"/>
             <a:r>
-              <a:rPr lang="en-US" smtClean="0"/>
+              <a:rPr lang="en-US"/>
               <a:t>Click to edit Master text styles</a:t>
             </a:r>
           </a:p>
@@ -1592,38 +1584,37 @@
           <a:p>
             <a:pPr lvl="0"/>
             <a:r>
-              <a:rPr lang="en-US" smtClean="0"/>
+              <a:rPr lang="en-US"/>
               <a:t>Click to edit Master text styles</a:t>
             </a:r>
           </a:p>
           <a:p>
             <a:pPr lvl="1"/>
             <a:r>
-              <a:rPr lang="en-US" smtClean="0"/>
+              <a:rPr lang="en-US"/>
               <a:t>Second level</a:t>
             </a:r>
           </a:p>
           <a:p>
             <a:pPr lvl="2"/>
             <a:r>
-              <a:rPr lang="en-US" smtClean="0"/>
+              <a:rPr lang="en-US"/>
               <a:t>Third level</a:t>
             </a:r>
           </a:p>
           <a:p>
             <a:pPr lvl="3"/>
             <a:r>
-              <a:rPr lang="en-US" smtClean="0"/>
+              <a:rPr lang="en-US"/>
               <a:t>Fourth level</a:t>
             </a:r>
           </a:p>
           <a:p>
             <a:pPr lvl="4"/>
             <a:r>
-              <a:rPr lang="en-US" smtClean="0"/>
+              <a:rPr lang="en-US"/>
               <a:t>Fifth level</a:t>
             </a:r>
-            <a:endParaRPr lang="en-US"/>
           </a:p>
         </p:txBody>
       </p:sp>
@@ -1645,7 +1636,7 @@
             <a:fld id="{4FB35DA8-B7CA-4C53-9105-91D1C2AF5D9E}" type="datetimeFigureOut">
               <a:rPr lang="en-US" smtClean="0"/>
               <a:pPr/>
-              <a:t>21-Jul-26</a:t>
+              <a:t>7/22/2026</a:t>
             </a:fld>
             <a:endParaRPr lang="en-US"/>
           </a:p>
@@ -1697,7 +1688,7 @@
     </p:spTree>
     <p:extLst>
       <p:ext uri="{BB962C8B-B14F-4D97-AF65-F5344CB8AC3E}">
-        <p14:creationId xmlns="" xmlns:p14="http://schemas.microsoft.com/office/powerpoint/2010/main" val="316377956"/>
+        <p14:creationId xmlns:p14="http://schemas.microsoft.com/office/powerpoint/2010/main" val="316377956"/>
       </p:ext>
     </p:extLst>
   </p:cSld>
@@ -1740,10 +1731,9 @@
           <a:lstStyle/>
           <a:p>
             <a:r>
-              <a:rPr lang="en-US" smtClean="0"/>
+              <a:rPr lang="en-US"/>
               <a:t>Click to edit Master title style</a:t>
             </a:r>
-            <a:endParaRPr lang="en-US"/>
           </a:p>
         </p:txBody>
       </p:sp>
@@ -1765,7 +1755,7 @@
             <a:fld id="{4FB35DA8-B7CA-4C53-9105-91D1C2AF5D9E}" type="datetimeFigureOut">
               <a:rPr lang="en-US" smtClean="0"/>
               <a:pPr/>
-              <a:t>21-Jul-26</a:t>
+              <a:t>7/22/2026</a:t>
             </a:fld>
             <a:endParaRPr lang="en-US"/>
           </a:p>
@@ -1817,7 +1807,7 @@
     </p:spTree>
     <p:extLst>
       <p:ext uri="{BB962C8B-B14F-4D97-AF65-F5344CB8AC3E}">
-        <p14:creationId xmlns="" xmlns:p14="http://schemas.microsoft.com/office/powerpoint/2010/main" val="3582745239"/>
+        <p14:creationId xmlns:p14="http://schemas.microsoft.com/office/powerpoint/2010/main" val="3582745239"/>
       </p:ext>
     </p:extLst>
   </p:cSld>
@@ -1862,7 +1852,7 @@
             <a:fld id="{4FB35DA8-B7CA-4C53-9105-91D1C2AF5D9E}" type="datetimeFigureOut">
               <a:rPr lang="en-US" smtClean="0"/>
               <a:pPr/>
-              <a:t>21-Jul-26</a:t>
+              <a:t>7/22/2026</a:t>
             </a:fld>
             <a:endParaRPr lang="en-US"/>
           </a:p>
@@ -1914,7 +1904,7 @@
     </p:spTree>
     <p:extLst>
       <p:ext uri="{BB962C8B-B14F-4D97-AF65-F5344CB8AC3E}">
-        <p14:creationId xmlns="" xmlns:p14="http://schemas.microsoft.com/office/powerpoint/2010/main" val="112541610"/>
+        <p14:creationId xmlns:p14="http://schemas.microsoft.com/office/powerpoint/2010/main" val="112541610"/>
       </p:ext>
     </p:extLst>
   </p:cSld>
@@ -1966,10 +1956,9 @@
           </a:lstStyle>
           <a:p>
             <a:r>
-              <a:rPr lang="en-US" smtClean="0"/>
+              <a:rPr lang="en-US"/>
               <a:t>Click to edit Master title style</a:t>
             </a:r>
-            <a:endParaRPr lang="en-US"/>
           </a:p>
         </p:txBody>
       </p:sp>
@@ -2023,38 +2012,37 @@
           <a:p>
             <a:pPr lvl="0"/>
             <a:r>
-              <a:rPr lang="en-US" smtClean="0"/>
+              <a:rPr lang="en-US"/>
               <a:t>Click to edit Master text styles</a:t>
             </a:r>
           </a:p>
           <a:p>
             <a:pPr lvl="1"/>
             <a:r>
-              <a:rPr lang="en-US" smtClean="0"/>
+              <a:rPr lang="en-US"/>
               <a:t>Second level</a:t>
             </a:r>
           </a:p>
           <a:p>
             <a:pPr lvl="2"/>
             <a:r>
-              <a:rPr lang="en-US" smtClean="0"/>
+              <a:rPr lang="en-US"/>
               <a:t>Third level</a:t>
             </a:r>
           </a:p>
           <a:p>
             <a:pPr lvl="3"/>
             <a:r>
-              <a:rPr lang="en-US" smtClean="0"/>
+              <a:rPr lang="en-US"/>
               <a:t>Fourth level</a:t>
             </a:r>
           </a:p>
           <a:p>
             <a:pPr lvl="4"/>
             <a:r>
-              <a:rPr lang="en-US" smtClean="0"/>
+              <a:rPr lang="en-US"/>
               <a:t>Fifth level</a:t>
             </a:r>
-            <a:endParaRPr lang="en-US"/>
           </a:p>
         </p:txBody>
       </p:sp>
@@ -2117,7 +2105,7 @@
           <a:p>
             <a:pPr lvl="0"/>
             <a:r>
-              <a:rPr lang="en-US" smtClean="0"/>
+              <a:rPr lang="en-US"/>
               <a:t>Click to edit Master text styles</a:t>
             </a:r>
           </a:p>
@@ -2141,7 +2129,7 @@
             <a:fld id="{4FB35DA8-B7CA-4C53-9105-91D1C2AF5D9E}" type="datetimeFigureOut">
               <a:rPr lang="en-US" smtClean="0"/>
               <a:pPr/>
-              <a:t>21-Jul-26</a:t>
+              <a:t>7/22/2026</a:t>
             </a:fld>
             <a:endParaRPr lang="en-US"/>
           </a:p>
@@ -2193,7 +2181,7 @@
     </p:spTree>
     <p:extLst>
       <p:ext uri="{BB962C8B-B14F-4D97-AF65-F5344CB8AC3E}">
-        <p14:creationId xmlns="" xmlns:p14="http://schemas.microsoft.com/office/powerpoint/2010/main" val="1351343155"/>
+        <p14:creationId xmlns:p14="http://schemas.microsoft.com/office/powerpoint/2010/main" val="1351343155"/>
       </p:ext>
     </p:extLst>
   </p:cSld>
@@ -2245,10 +2233,9 @@
           </a:lstStyle>
           <a:p>
             <a:r>
-              <a:rPr lang="en-US" smtClean="0"/>
+              <a:rPr lang="en-US"/>
               <a:t>Click to edit Master title style</a:t>
             </a:r>
-            <a:endParaRPr lang="en-US"/>
           </a:p>
         </p:txBody>
       </p:sp>
@@ -2372,7 +2359,7 @@
           <a:p>
             <a:pPr lvl="0"/>
             <a:r>
-              <a:rPr lang="en-US" smtClean="0"/>
+              <a:rPr lang="en-US"/>
               <a:t>Click to edit Master text styles</a:t>
             </a:r>
           </a:p>
@@ -2396,7 +2383,7 @@
             <a:fld id="{4FB35DA8-B7CA-4C53-9105-91D1C2AF5D9E}" type="datetimeFigureOut">
               <a:rPr lang="en-US" smtClean="0"/>
               <a:pPr/>
-              <a:t>21-Jul-26</a:t>
+              <a:t>7/22/2026</a:t>
             </a:fld>
             <a:endParaRPr lang="en-US"/>
           </a:p>
@@ -2448,7 +2435,7 @@
     </p:spTree>
     <p:extLst>
       <p:ext uri="{BB962C8B-B14F-4D97-AF65-F5344CB8AC3E}">
-        <p14:creationId xmlns="" xmlns:p14="http://schemas.microsoft.com/office/powerpoint/2010/main" val="2987119547"/>
+        <p14:creationId xmlns:p14="http://schemas.microsoft.com/office/powerpoint/2010/main" val="2987119547"/>
       </p:ext>
     </p:extLst>
   </p:cSld>
@@ -2506,10 +2493,9 @@
           <a:lstStyle/>
           <a:p>
             <a:r>
-              <a:rPr lang="en-US" smtClean="0"/>
+              <a:rPr lang="en-US"/>
               <a:t>Click to edit Master title style</a:t>
             </a:r>
-            <a:endParaRPr lang="en-US"/>
           </a:p>
         </p:txBody>
       </p:sp>
@@ -2540,38 +2526,37 @@
           <a:p>
             <a:pPr lvl="0"/>
             <a:r>
-              <a:rPr lang="en-US" smtClean="0"/>
+              <a:rPr lang="en-US"/>
               <a:t>Click to edit Master text styles</a:t>
             </a:r>
           </a:p>
           <a:p>
             <a:pPr lvl="1"/>
             <a:r>
-              <a:rPr lang="en-US" smtClean="0"/>
+              <a:rPr lang="en-US"/>
               <a:t>Second level</a:t>
             </a:r>
           </a:p>
           <a:p>
             <a:pPr lvl="2"/>
             <a:r>
-              <a:rPr lang="en-US" smtClean="0"/>
+              <a:rPr lang="en-US"/>
               <a:t>Third level</a:t>
             </a:r>
           </a:p>
           <a:p>
             <a:pPr lvl="3"/>
             <a:r>
-              <a:rPr lang="en-US" smtClean="0"/>
+              <a:rPr lang="en-US"/>
               <a:t>Fourth level</a:t>
             </a:r>
           </a:p>
           <a:p>
             <a:pPr lvl="4"/>
             <a:r>
-              <a:rPr lang="en-US" smtClean="0"/>
+              <a:rPr lang="en-US"/>
               <a:t>Fifth level</a:t>
             </a:r>
-            <a:endParaRPr lang="en-US"/>
           </a:p>
         </p:txBody>
       </p:sp>
@@ -2611,7 +2596,7 @@
             <a:fld id="{4FB35DA8-B7CA-4C53-9105-91D1C2AF5D9E}" type="datetimeFigureOut">
               <a:rPr lang="en-US" smtClean="0"/>
               <a:pPr/>
-              <a:t>21-Jul-26</a:t>
+              <a:t>7/22/2026</a:t>
             </a:fld>
             <a:endParaRPr lang="en-US"/>
           </a:p>
@@ -2699,7 +2684,7 @@
     </p:spTree>
     <p:extLst>
       <p:ext uri="{BB962C8B-B14F-4D97-AF65-F5344CB8AC3E}">
-        <p14:creationId xmlns="" xmlns:p14="http://schemas.microsoft.com/office/powerpoint/2010/main" val="2490179765"/>
+        <p14:creationId xmlns:p14="http://schemas.microsoft.com/office/powerpoint/2010/main" val="2490179765"/>
       </p:ext>
     </p:extLst>
   </p:cSld>
@@ -3075,20 +3060,13 @@
     </p:spTree>
     <p:extLst>
       <p:ext uri="{BB962C8B-B14F-4D97-AF65-F5344CB8AC3E}">
-        <p14:creationId xmlns="" xmlns:p14="http://schemas.microsoft.com/office/powerpoint/2010/main" val="3998511274"/>
+        <p14:creationId xmlns:p14="http://schemas.microsoft.com/office/powerpoint/2010/main" val="3998511274"/>
       </p:ext>
     </p:extLst>
   </p:cSld>
   <p:clrMapOvr>
     <a:masterClrMapping/>
   </p:clrMapOvr>
-  <p:timing>
-    <p:tnLst>
-      <p:par>
-        <p:cTn id="1" dur="indefinite" restart="never" nodeType="tmRoot"/>
-      </p:par>
-    </p:tnLst>
-  </p:timing>
 </p:sld>
 </file>
 
@@ -3125,7 +3103,7 @@
           <a:lstStyle/>
           <a:p>
             <a:r>
-              <a:rPr lang="en-US" b="1" dirty="0" smtClean="0"/>
+              <a:rPr lang="en-US" b="1" dirty="0"/>
               <a:t>K-means clustering with k=3  (same previous example)</a:t>
             </a:r>
             <a:endParaRPr lang="en-US" dirty="0"/>
@@ -3267,7 +3245,7 @@
     </p:spTree>
     <p:extLst>
       <p:ext uri="{BB962C8B-B14F-4D97-AF65-F5344CB8AC3E}">
-        <p14:creationId xmlns="" xmlns:p14="http://schemas.microsoft.com/office/powerpoint/2010/main" val="2270902524"/>
+        <p14:creationId xmlns:p14="http://schemas.microsoft.com/office/powerpoint/2010/main" val="2270902524"/>
       </p:ext>
     </p:extLst>
   </p:cSld>
@@ -3396,7 +3374,7 @@
     </p:spTree>
     <p:extLst>
       <p:ext uri="{BB962C8B-B14F-4D97-AF65-F5344CB8AC3E}">
-        <p14:creationId xmlns="" xmlns:p14="http://schemas.microsoft.com/office/powerpoint/2010/main" val="1083136414"/>
+        <p14:creationId xmlns:p14="http://schemas.microsoft.com/office/powerpoint/2010/main" val="1083136414"/>
       </p:ext>
     </p:extLst>
   </p:cSld>
@@ -3516,7 +3494,7 @@
     </p:spTree>
     <p:extLst>
       <p:ext uri="{BB962C8B-B14F-4D97-AF65-F5344CB8AC3E}">
-        <p14:creationId xmlns="" xmlns:p14="http://schemas.microsoft.com/office/powerpoint/2010/main" val="2779947869"/>
+        <p14:creationId xmlns:p14="http://schemas.microsoft.com/office/powerpoint/2010/main" val="2779947869"/>
       </p:ext>
     </p:extLst>
   </p:cSld>
@@ -3527,6 +3505,828 @@
 </file>
 
 <file path=ppt/slides/slide14.xml><?xml version="1.0" encoding="utf-8"?>
+<p:sld xmlns:a="http://schemas.openxmlformats.org/drawingml/2006/main" xmlns:r="http://schemas.openxmlformats.org/officeDocument/2006/relationships" xmlns:p="http://schemas.openxmlformats.org/presentationml/2006/main">
+  <p:cSld>
+    <p:spTree>
+      <p:nvGrpSpPr>
+        <p:cNvPr id="1" name=""/>
+        <p:cNvGrpSpPr/>
+        <p:nvPr/>
+      </p:nvGrpSpPr>
+      <p:grpSpPr>
+        <a:xfrm>
+          <a:off x="0" y="0"/>
+          <a:ext cx="0" cy="0"/>
+          <a:chOff x="0" y="0"/>
+          <a:chExt cx="0" cy="0"/>
+        </a:xfrm>
+      </p:grpSpPr>
+      <p:sp>
+        <p:nvSpPr>
+          <p:cNvPr id="2" name="Title 1">
+            <a:extLst>
+              <a:ext uri="{FF2B5EF4-FFF2-40B4-BE49-F238E27FC236}">
+                <a16:creationId xmlns:a16="http://schemas.microsoft.com/office/drawing/2014/main" id="{E4D62BB7-C686-5E00-31EF-6F9F145F8E7F}"/>
+              </a:ext>
+            </a:extLst>
+          </p:cNvPr>
+          <p:cNvSpPr>
+            <a:spLocks noGrp="1"/>
+          </p:cNvSpPr>
+          <p:nvPr>
+            <p:ph type="title"/>
+          </p:nvPr>
+        </p:nvSpPr>
+        <p:spPr/>
+        <p:txBody>
+          <a:bodyPr/>
+          <a:lstStyle/>
+          <a:p>
+            <a:endParaRPr lang="en-US"/>
+          </a:p>
+        </p:txBody>
+      </p:sp>
+      <p:sp>
+        <p:nvSpPr>
+          <p:cNvPr id="3" name="Content Placeholder 2">
+            <a:extLst>
+              <a:ext uri="{FF2B5EF4-FFF2-40B4-BE49-F238E27FC236}">
+                <a16:creationId xmlns:a16="http://schemas.microsoft.com/office/drawing/2014/main" id="{9ADC0B90-EDCF-5F00-A92D-29F035B89379}"/>
+              </a:ext>
+            </a:extLst>
+          </p:cNvPr>
+          <p:cNvSpPr>
+            <a:spLocks noGrp="1"/>
+          </p:cNvSpPr>
+          <p:nvPr>
+            <p:ph idx="1"/>
+          </p:nvPr>
+        </p:nvSpPr>
+        <p:spPr/>
+        <p:txBody>
+          <a:bodyPr/>
+          <a:lstStyle/>
+          <a:p>
+            <a:r>
+              <a:rPr lang="en-US" sz="3200" b="1" dirty="0"/>
+              <a:t>KNN </a:t>
+            </a:r>
+            <a:r>
+              <a:rPr lang="en-US" sz="3200" b="1" dirty="0" err="1"/>
+              <a:t>অ্যালগরিদম</a:t>
+            </a:r>
+            <a:r>
+              <a:rPr lang="en-US" sz="3200" b="1" dirty="0"/>
+              <a:t>:</a:t>
+            </a:r>
+          </a:p>
+          <a:p>
+            <a:pPr lvl="1"/>
+            <a:r>
+              <a:rPr lang="en-US" sz="2800" b="1" dirty="0"/>
+              <a:t>"</a:t>
+            </a:r>
+            <a:r>
+              <a:rPr lang="en-US" sz="2800" b="1" dirty="0" err="1"/>
+              <a:t>তুমি</a:t>
+            </a:r>
+            <a:r>
+              <a:rPr lang="en-US" sz="2800" b="1" dirty="0"/>
+              <a:t> </a:t>
+            </a:r>
+            <a:r>
+              <a:rPr lang="en-US" sz="2800" b="1" dirty="0" err="1"/>
+              <a:t>আমাকে</a:t>
+            </a:r>
+            <a:r>
+              <a:rPr lang="en-US" sz="2800" b="1" dirty="0"/>
+              <a:t> </a:t>
+            </a:r>
+            <a:r>
+              <a:rPr lang="en-US" sz="2800" b="1" dirty="0" err="1"/>
+              <a:t>তোমার</a:t>
+            </a:r>
+            <a:r>
+              <a:rPr lang="en-US" sz="2800" b="1" dirty="0"/>
+              <a:t> ৩ </a:t>
+            </a:r>
+            <a:r>
+              <a:rPr lang="en-US" sz="2800" b="1" dirty="0" err="1"/>
+              <a:t>জন</a:t>
+            </a:r>
+            <a:r>
+              <a:rPr lang="en-US" sz="2800" b="1" dirty="0"/>
+              <a:t> </a:t>
+            </a:r>
+            <a:r>
+              <a:rPr lang="en-US" sz="2800" b="1" dirty="0" err="1"/>
+              <a:t>নিকটতম</a:t>
+            </a:r>
+            <a:r>
+              <a:rPr lang="en-US" sz="2800" b="1" dirty="0"/>
+              <a:t> </a:t>
+            </a:r>
+            <a:r>
+              <a:rPr lang="en-US" sz="2800" b="1" dirty="0" err="1"/>
+              <a:t>প্রতিবেশীর</a:t>
+            </a:r>
+            <a:r>
+              <a:rPr lang="en-US" sz="2800" b="1" dirty="0"/>
+              <a:t> </a:t>
+            </a:r>
+            <a:r>
+              <a:rPr lang="en-US" sz="2800" b="1" dirty="0" err="1"/>
+              <a:t>তথ্য</a:t>
+            </a:r>
+            <a:r>
+              <a:rPr lang="en-US" sz="2800" b="1" dirty="0"/>
+              <a:t> </a:t>
+            </a:r>
+            <a:r>
+              <a:rPr lang="en-US" sz="2800" b="1" dirty="0" err="1"/>
+              <a:t>দাও</a:t>
+            </a:r>
+            <a:r>
+              <a:rPr lang="en-US" sz="2800" b="1" dirty="0"/>
+              <a:t>, </a:t>
+            </a:r>
+            <a:r>
+              <a:rPr lang="en-US" sz="2800" b="1" dirty="0" err="1"/>
+              <a:t>আমি</a:t>
+            </a:r>
+            <a:r>
+              <a:rPr lang="en-US" sz="2800" b="1" dirty="0"/>
+              <a:t> </a:t>
+            </a:r>
+            <a:r>
+              <a:rPr lang="en-US" sz="2800" b="1" dirty="0" err="1"/>
+              <a:t>বলে</a:t>
+            </a:r>
+            <a:r>
+              <a:rPr lang="en-US" sz="2800" b="1" dirty="0"/>
+              <a:t> </a:t>
+            </a:r>
+            <a:r>
+              <a:rPr lang="en-US" sz="2800" b="1" dirty="0" err="1"/>
+              <a:t>দেব</a:t>
+            </a:r>
+            <a:r>
+              <a:rPr lang="en-US" sz="2800" b="1" dirty="0"/>
+              <a:t> </a:t>
+            </a:r>
+            <a:r>
+              <a:rPr lang="en-US" sz="2800" b="1" dirty="0" err="1"/>
+              <a:t>তুমি</a:t>
+            </a:r>
+            <a:r>
+              <a:rPr lang="en-US" sz="2800" b="1" dirty="0"/>
+              <a:t> </a:t>
+            </a:r>
+            <a:r>
+              <a:rPr lang="en-US" sz="2800" b="1" dirty="0" err="1"/>
+              <a:t>কে</a:t>
+            </a:r>
+            <a:r>
+              <a:rPr lang="en-US" sz="2800" b="1" dirty="0"/>
+              <a:t>!"</a:t>
+            </a:r>
+            <a:endParaRPr lang="en-US" sz="2800" dirty="0"/>
+          </a:p>
+          <a:p>
+            <a:pPr lvl="1"/>
+            <a:r>
+              <a:rPr lang="en-US" sz="2800" b="1" dirty="0"/>
+              <a:t>K:</a:t>
+            </a:r>
+            <a:r>
+              <a:rPr lang="en-US" sz="2800" dirty="0"/>
+              <a:t> </a:t>
+            </a:r>
+            <a:r>
+              <a:rPr lang="en-US" sz="2800" dirty="0" err="1"/>
+              <a:t>আপনি</a:t>
+            </a:r>
+            <a:r>
+              <a:rPr lang="en-US" sz="2800" dirty="0"/>
+              <a:t> </a:t>
+            </a:r>
+            <a:r>
+              <a:rPr lang="en-US" sz="2800" dirty="0" err="1"/>
+              <a:t>কয়জন</a:t>
+            </a:r>
+            <a:r>
+              <a:rPr lang="en-US" sz="2800" dirty="0"/>
+              <a:t> </a:t>
+            </a:r>
+            <a:r>
+              <a:rPr lang="en-US" sz="2800" dirty="0" err="1"/>
+              <a:t>নিকটতম</a:t>
+            </a:r>
+            <a:r>
+              <a:rPr lang="en-US" sz="2800" dirty="0"/>
+              <a:t> </a:t>
+            </a:r>
+            <a:r>
+              <a:rPr lang="en-US" sz="2800" dirty="0" err="1"/>
+              <a:t>প্রতিবেশীর</a:t>
+            </a:r>
+            <a:r>
+              <a:rPr lang="en-US" sz="2800" dirty="0"/>
+              <a:t> </a:t>
+            </a:r>
+            <a:r>
+              <a:rPr lang="en-US" sz="2800" dirty="0" err="1"/>
+              <a:t>সাহায্য</a:t>
+            </a:r>
+            <a:r>
+              <a:rPr lang="en-US" sz="2800" dirty="0"/>
+              <a:t> </a:t>
+            </a:r>
+            <a:r>
+              <a:rPr lang="en-US" sz="2800" dirty="0" err="1"/>
+              <a:t>নিতে</a:t>
+            </a:r>
+            <a:r>
+              <a:rPr lang="en-US" sz="2800" dirty="0"/>
+              <a:t> </a:t>
+            </a:r>
+            <a:r>
+              <a:rPr lang="en-US" sz="2800" dirty="0" err="1"/>
+              <a:t>চান</a:t>
+            </a:r>
+            <a:r>
+              <a:rPr lang="en-US" sz="2800" dirty="0"/>
+              <a:t> (</a:t>
+            </a:r>
+            <a:r>
+              <a:rPr lang="en-US" sz="2800" dirty="0" err="1"/>
+              <a:t>এখানে</a:t>
+            </a:r>
+            <a:r>
+              <a:rPr lang="en-US" sz="2800" dirty="0"/>
+              <a:t> K = 3)।</a:t>
+            </a:r>
+          </a:p>
+          <a:p>
+            <a:pPr lvl="1"/>
+            <a:r>
+              <a:rPr lang="en-US" sz="2800" b="1" dirty="0"/>
+              <a:t>Nearest Neighbor:</a:t>
+            </a:r>
+            <a:r>
+              <a:rPr lang="en-US" sz="2800" dirty="0"/>
+              <a:t> </a:t>
+            </a:r>
+            <a:r>
+              <a:rPr lang="en-US" sz="2800" dirty="0" err="1"/>
+              <a:t>গাণিতিক</a:t>
+            </a:r>
+            <a:r>
+              <a:rPr lang="en-US" sz="2800" dirty="0"/>
+              <a:t> </a:t>
+            </a:r>
+            <a:r>
+              <a:rPr lang="en-US" sz="2800" dirty="0" err="1"/>
+              <a:t>দূরত্ব</a:t>
+            </a:r>
+            <a:r>
+              <a:rPr lang="en-US" sz="2800" dirty="0"/>
+              <a:t> </a:t>
+            </a:r>
+            <a:r>
+              <a:rPr lang="en-US" sz="2800" dirty="0" err="1"/>
+              <a:t>মেপে</a:t>
+            </a:r>
+            <a:r>
+              <a:rPr lang="en-US" sz="2800" dirty="0"/>
+              <a:t> </a:t>
+            </a:r>
+            <a:r>
+              <a:rPr lang="en-US" sz="2800" dirty="0" err="1"/>
+              <a:t>সবচেয়ে</a:t>
+            </a:r>
+            <a:r>
+              <a:rPr lang="en-US" sz="2800" dirty="0"/>
+              <a:t> </a:t>
+            </a:r>
+            <a:r>
+              <a:rPr lang="en-US" sz="2800" dirty="0" err="1"/>
+              <a:t>কাছাকাছি</a:t>
+            </a:r>
+            <a:r>
+              <a:rPr lang="en-US" sz="2800" dirty="0"/>
+              <a:t> </a:t>
+            </a:r>
+            <a:r>
+              <a:rPr lang="en-US" sz="2800" dirty="0" err="1"/>
+              <a:t>থাকা</a:t>
+            </a:r>
+            <a:r>
+              <a:rPr lang="en-US" sz="2800" dirty="0"/>
+              <a:t> </a:t>
+            </a:r>
+            <a:r>
+              <a:rPr lang="en-US" sz="2800" dirty="0" err="1"/>
+              <a:t>ডেটা</a:t>
+            </a:r>
+            <a:r>
+              <a:rPr lang="en-US" sz="2800" dirty="0"/>
+              <a:t> </a:t>
+            </a:r>
+            <a:r>
+              <a:rPr lang="en-US" sz="2800" dirty="0" err="1"/>
+              <a:t>খুঁজে</a:t>
+            </a:r>
+            <a:r>
+              <a:rPr lang="en-US" sz="2800" dirty="0"/>
+              <a:t> </a:t>
+            </a:r>
+            <a:r>
+              <a:rPr lang="en-US" sz="2800" dirty="0" err="1"/>
+              <a:t>বের</a:t>
+            </a:r>
+            <a:r>
+              <a:rPr lang="en-US" sz="2800" dirty="0"/>
+              <a:t> </a:t>
+            </a:r>
+            <a:r>
+              <a:rPr lang="en-US" sz="2800" dirty="0" err="1"/>
+              <a:t>করা</a:t>
+            </a:r>
+            <a:r>
+              <a:rPr lang="en-US" sz="2800" dirty="0"/>
+              <a:t>।</a:t>
+            </a:r>
+          </a:p>
+          <a:p>
+            <a:pPr lvl="1"/>
+            <a:r>
+              <a:rPr lang="en-US" sz="2800" b="1" dirty="0"/>
+              <a:t>Classification:</a:t>
+            </a:r>
+            <a:r>
+              <a:rPr lang="en-US" sz="2800" dirty="0"/>
+              <a:t> </a:t>
+            </a:r>
+            <a:r>
+              <a:rPr lang="en-US" sz="2800" dirty="0" err="1"/>
+              <a:t>সংখ্যাগরিষ্ঠের</a:t>
+            </a:r>
+            <a:r>
+              <a:rPr lang="en-US" sz="2800" dirty="0"/>
+              <a:t> </a:t>
+            </a:r>
+            <a:r>
+              <a:rPr lang="en-US" sz="2800" dirty="0" err="1"/>
+              <a:t>ভোটের</a:t>
+            </a:r>
+            <a:r>
+              <a:rPr lang="en-US" sz="2800" dirty="0"/>
+              <a:t> </a:t>
+            </a:r>
+            <a:r>
+              <a:rPr lang="en-US" sz="2800" dirty="0" err="1"/>
+              <a:t>ভিত্তিতে</a:t>
+            </a:r>
+            <a:r>
+              <a:rPr lang="en-US" sz="2800" dirty="0"/>
+              <a:t> </a:t>
+            </a:r>
+            <a:r>
+              <a:rPr lang="en-US" sz="2800" dirty="0" err="1"/>
+              <a:t>নতুন</a:t>
+            </a:r>
+            <a:r>
+              <a:rPr lang="en-US" sz="2800" dirty="0"/>
+              <a:t> </a:t>
+            </a:r>
+            <a:r>
+              <a:rPr lang="en-US" sz="2800" dirty="0" err="1"/>
+              <a:t>ডেটার</a:t>
+            </a:r>
+            <a:r>
+              <a:rPr lang="en-US" sz="2800" dirty="0"/>
+              <a:t> </a:t>
+            </a:r>
+            <a:r>
+              <a:rPr lang="en-US" sz="2800" dirty="0" err="1"/>
+              <a:t>দল</a:t>
+            </a:r>
+            <a:r>
+              <a:rPr lang="en-US" sz="2800" dirty="0"/>
+              <a:t> </a:t>
+            </a:r>
+            <a:r>
+              <a:rPr lang="en-US" sz="2800" dirty="0" err="1"/>
+              <a:t>বা</a:t>
+            </a:r>
+            <a:r>
+              <a:rPr lang="en-US" sz="2800" dirty="0"/>
+              <a:t> </a:t>
+            </a:r>
+            <a:r>
+              <a:rPr lang="en-US" sz="2800" dirty="0" err="1"/>
+              <a:t>ক্যাটাগরি</a:t>
+            </a:r>
+            <a:r>
+              <a:rPr lang="en-US" sz="2800" dirty="0"/>
+              <a:t> (Pass/Fail) </a:t>
+            </a:r>
+            <a:r>
+              <a:rPr lang="en-US" sz="2800" dirty="0" err="1"/>
+              <a:t>নির্ধারণ</a:t>
+            </a:r>
+            <a:r>
+              <a:rPr lang="en-US" sz="2800" dirty="0"/>
+              <a:t> </a:t>
+            </a:r>
+            <a:r>
+              <a:rPr lang="en-US" sz="2800" dirty="0" err="1"/>
+              <a:t>করা</a:t>
+            </a:r>
+            <a:r>
+              <a:rPr lang="en-US" sz="2800" dirty="0"/>
+              <a:t>।</a:t>
+            </a:r>
+          </a:p>
+          <a:p>
+            <a:endParaRPr lang="en-US" dirty="0"/>
+          </a:p>
+        </p:txBody>
+      </p:sp>
+    </p:spTree>
+    <p:extLst>
+      <p:ext uri="{BB962C8B-B14F-4D97-AF65-F5344CB8AC3E}">
+        <p14:creationId xmlns:p14="http://schemas.microsoft.com/office/powerpoint/2010/main" val="631649654"/>
+      </p:ext>
+    </p:extLst>
+  </p:cSld>
+  <p:clrMapOvr>
+    <a:masterClrMapping/>
+  </p:clrMapOvr>
+</p:sld>
+</file>
+
+<file path=ppt/slides/slide15.xml><?xml version="1.0" encoding="utf-8"?>
+<p:sld xmlns:a="http://schemas.openxmlformats.org/drawingml/2006/main" xmlns:r="http://schemas.openxmlformats.org/officeDocument/2006/relationships" xmlns:p="http://schemas.openxmlformats.org/presentationml/2006/main">
+  <p:cSld>
+    <p:spTree>
+      <p:nvGrpSpPr>
+        <p:cNvPr id="1" name=""/>
+        <p:cNvGrpSpPr/>
+        <p:nvPr/>
+      </p:nvGrpSpPr>
+      <p:grpSpPr>
+        <a:xfrm>
+          <a:off x="0" y="0"/>
+          <a:ext cx="0" cy="0"/>
+          <a:chOff x="0" y="0"/>
+          <a:chExt cx="0" cy="0"/>
+        </a:xfrm>
+      </p:grpSpPr>
+      <p:sp>
+        <p:nvSpPr>
+          <p:cNvPr id="2" name="Title 1">
+            <a:extLst>
+              <a:ext uri="{FF2B5EF4-FFF2-40B4-BE49-F238E27FC236}">
+                <a16:creationId xmlns:a16="http://schemas.microsoft.com/office/drawing/2014/main" id="{F1F0B0EF-7D63-93A2-23F0-68D4450C2CFC}"/>
+              </a:ext>
+            </a:extLst>
+          </p:cNvPr>
+          <p:cNvSpPr>
+            <a:spLocks noGrp="1"/>
+          </p:cNvSpPr>
+          <p:nvPr>
+            <p:ph type="title"/>
+          </p:nvPr>
+        </p:nvSpPr>
+        <p:spPr/>
+        <p:txBody>
+          <a:bodyPr/>
+          <a:lstStyle/>
+          <a:p>
+            <a:endParaRPr lang="en-US"/>
+          </a:p>
+        </p:txBody>
+      </p:sp>
+      <p:sp>
+        <p:nvSpPr>
+          <p:cNvPr id="3" name="Content Placeholder 2">
+            <a:extLst>
+              <a:ext uri="{FF2B5EF4-FFF2-40B4-BE49-F238E27FC236}">
+                <a16:creationId xmlns:a16="http://schemas.microsoft.com/office/drawing/2014/main" id="{62F672D4-C145-807B-0A58-8861A6358A7A}"/>
+              </a:ext>
+            </a:extLst>
+          </p:cNvPr>
+          <p:cNvSpPr>
+            <a:spLocks noGrp="1"/>
+          </p:cNvSpPr>
+          <p:nvPr>
+            <p:ph idx="1"/>
+          </p:nvPr>
+        </p:nvSpPr>
+        <p:spPr/>
+        <p:txBody>
+          <a:bodyPr/>
+          <a:lstStyle/>
+          <a:p>
+            <a:r>
+              <a:rPr lang="en-US" dirty="0"/>
+              <a:t>NN </a:t>
+            </a:r>
+            <a:r>
+              <a:rPr lang="en-US" dirty="0" err="1"/>
+              <a:t>অ্যালগরিদমে</a:t>
+            </a:r>
+            <a:r>
+              <a:rPr lang="en-US" dirty="0"/>
+              <a:t> </a:t>
+            </a:r>
+            <a:r>
+              <a:rPr lang="en-US" dirty="0" err="1"/>
+              <a:t>সাধারণত</a:t>
+            </a:r>
+            <a:r>
+              <a:rPr lang="en-US" dirty="0"/>
+              <a:t> K-</a:t>
+            </a:r>
+            <a:r>
+              <a:rPr lang="en-US" dirty="0" err="1"/>
+              <a:t>এর</a:t>
+            </a:r>
+            <a:r>
+              <a:rPr lang="en-US" dirty="0"/>
+              <a:t> </a:t>
+            </a:r>
+            <a:r>
+              <a:rPr lang="en-US" dirty="0" err="1"/>
+              <a:t>মান</a:t>
+            </a:r>
+            <a:r>
+              <a:rPr lang="en-US" dirty="0"/>
+              <a:t> </a:t>
+            </a:r>
+            <a:r>
+              <a:rPr lang="en-US" b="1" dirty="0" err="1"/>
+              <a:t>বিজোড়</a:t>
+            </a:r>
+            <a:r>
+              <a:rPr lang="en-US" b="1" dirty="0"/>
+              <a:t> </a:t>
+            </a:r>
+            <a:r>
+              <a:rPr lang="en-US" b="1" dirty="0" err="1"/>
+              <a:t>সংখ্যা</a:t>
+            </a:r>
+            <a:r>
+              <a:rPr lang="en-US" dirty="0"/>
+              <a:t> (</a:t>
+            </a:r>
+            <a:r>
+              <a:rPr lang="en-US" dirty="0" err="1"/>
+              <a:t>যেমন</a:t>
+            </a:r>
+            <a:r>
+              <a:rPr lang="en-US" dirty="0"/>
+              <a:t>: 3, 5, 7) </a:t>
+            </a:r>
+            <a:r>
+              <a:rPr lang="en-US" dirty="0" err="1"/>
+              <a:t>রাখা</a:t>
+            </a:r>
+            <a:r>
+              <a:rPr lang="en-US" dirty="0"/>
+              <a:t> </a:t>
+            </a:r>
+            <a:r>
+              <a:rPr lang="en-US" dirty="0" err="1"/>
+              <a:t>হয়</a:t>
+            </a:r>
+            <a:r>
+              <a:rPr lang="en-US" dirty="0"/>
+              <a:t>। </a:t>
+            </a:r>
+          </a:p>
+          <a:p>
+            <a:r>
+              <a:rPr lang="en-US" dirty="0" err="1"/>
+              <a:t>কারণ</a:t>
+            </a:r>
+            <a:r>
+              <a:rPr lang="en-US" dirty="0"/>
+              <a:t> </a:t>
+            </a:r>
+            <a:r>
+              <a:rPr lang="en-US" dirty="0" err="1"/>
+              <a:t>জোড়</a:t>
+            </a:r>
+            <a:r>
+              <a:rPr lang="en-US" dirty="0"/>
+              <a:t> </a:t>
+            </a:r>
+            <a:r>
+              <a:rPr lang="en-US" dirty="0" err="1"/>
+              <a:t>সংখ্যা</a:t>
+            </a:r>
+            <a:r>
+              <a:rPr lang="en-US" dirty="0"/>
+              <a:t> (K = 4) </a:t>
+            </a:r>
+            <a:r>
+              <a:rPr lang="en-US" dirty="0" err="1"/>
+              <a:t>রাখলে</a:t>
+            </a:r>
+            <a:r>
+              <a:rPr lang="en-US" dirty="0"/>
+              <a:t> </a:t>
+            </a:r>
+            <a:r>
+              <a:rPr lang="en-US" dirty="0" err="1"/>
+              <a:t>অনেক</a:t>
+            </a:r>
+            <a:r>
+              <a:rPr lang="en-US" dirty="0"/>
+              <a:t> </a:t>
+            </a:r>
+            <a:r>
+              <a:rPr lang="en-US" dirty="0" err="1"/>
+              <a:t>সময়</a:t>
+            </a:r>
+            <a:r>
+              <a:rPr lang="en-US" dirty="0"/>
+              <a:t> </a:t>
+            </a:r>
+            <a:r>
+              <a:rPr lang="en-US" dirty="0" err="1"/>
+              <a:t>সমানে-সমানে</a:t>
+            </a:r>
+            <a:r>
+              <a:rPr lang="en-US" dirty="0"/>
+              <a:t> </a:t>
+            </a:r>
+            <a:r>
+              <a:rPr lang="en-US" dirty="0" err="1"/>
+              <a:t>ভোট</a:t>
+            </a:r>
+            <a:r>
+              <a:rPr lang="en-US" dirty="0"/>
+              <a:t> </a:t>
+            </a:r>
+            <a:r>
+              <a:rPr lang="en-US" dirty="0" err="1"/>
+              <a:t>টাই</a:t>
+            </a:r>
+            <a:r>
+              <a:rPr lang="en-US" dirty="0"/>
+              <a:t> (Tie) </a:t>
+            </a:r>
+            <a:r>
+              <a:rPr lang="en-US" dirty="0" err="1"/>
+              <a:t>হয়ে</a:t>
+            </a:r>
+            <a:r>
+              <a:rPr lang="en-US" dirty="0"/>
+              <a:t> </a:t>
+            </a:r>
+            <a:r>
+              <a:rPr lang="en-US" dirty="0" err="1"/>
+              <a:t>যাওয়ার</a:t>
+            </a:r>
+            <a:r>
+              <a:rPr lang="en-US" dirty="0"/>
+              <a:t> </a:t>
+            </a:r>
+            <a:r>
+              <a:rPr lang="en-US" dirty="0" err="1"/>
+              <a:t>ঝুঁকি</a:t>
+            </a:r>
+            <a:r>
+              <a:rPr lang="en-US" dirty="0"/>
+              <a:t> </a:t>
+            </a:r>
+            <a:r>
+              <a:rPr lang="en-US" dirty="0" err="1"/>
+              <a:t>থাকে</a:t>
+            </a:r>
+            <a:r>
+              <a:rPr lang="en-US" dirty="0"/>
+              <a:t> (</a:t>
+            </a:r>
+            <a:r>
+              <a:rPr lang="en-US" dirty="0" err="1"/>
+              <a:t>যেমন</a:t>
+            </a:r>
+            <a:r>
+              <a:rPr lang="en-US" dirty="0"/>
+              <a:t>: ২ </a:t>
+            </a:r>
+            <a:r>
+              <a:rPr lang="en-US" dirty="0" err="1"/>
+              <a:t>টি</a:t>
+            </a:r>
+            <a:r>
+              <a:rPr lang="en-US" dirty="0"/>
+              <a:t> Pass ও ২ </a:t>
+            </a:r>
+            <a:r>
+              <a:rPr lang="en-US" dirty="0" err="1"/>
+              <a:t>টি</a:t>
+            </a:r>
+            <a:r>
+              <a:rPr lang="en-US" dirty="0"/>
+              <a:t> Fail)। </a:t>
+            </a:r>
+          </a:p>
+          <a:p>
+            <a:r>
+              <a:rPr lang="en-US" dirty="0" err="1"/>
+              <a:t>তবে</a:t>
+            </a:r>
+            <a:r>
+              <a:rPr lang="en-US" dirty="0"/>
+              <a:t> </a:t>
+            </a:r>
+            <a:r>
+              <a:rPr lang="en-US" dirty="0" err="1"/>
+              <a:t>এই</a:t>
+            </a:r>
+            <a:r>
+              <a:rPr lang="en-US" dirty="0"/>
+              <a:t> </a:t>
+            </a:r>
+            <a:r>
+              <a:rPr lang="en-US" dirty="0" err="1"/>
+              <a:t>উদাহরণের</a:t>
+            </a:r>
+            <a:r>
+              <a:rPr lang="en-US" dirty="0"/>
+              <a:t> </a:t>
+            </a:r>
+            <a:r>
+              <a:rPr lang="en-US" dirty="0" err="1"/>
+              <a:t>ক্ষেত্রে</a:t>
+            </a:r>
+            <a:r>
+              <a:rPr lang="en-US" dirty="0"/>
+              <a:t> ৩টি Pass </a:t>
+            </a:r>
+            <a:r>
+              <a:rPr lang="en-US" dirty="0" err="1"/>
+              <a:t>থাকায়</a:t>
+            </a:r>
+            <a:r>
+              <a:rPr lang="en-US" dirty="0"/>
+              <a:t> </a:t>
+            </a:r>
+            <a:r>
+              <a:rPr lang="en-US" dirty="0" err="1"/>
+              <a:t>স্পষ্ট</a:t>
+            </a:r>
+            <a:r>
+              <a:rPr lang="en-US" dirty="0"/>
+              <a:t> </a:t>
+            </a:r>
+            <a:r>
+              <a:rPr lang="en-US" dirty="0" err="1"/>
+              <a:t>সিদ্ধান্ত</a:t>
+            </a:r>
+            <a:r>
+              <a:rPr lang="en-US" dirty="0"/>
+              <a:t> </a:t>
+            </a:r>
+            <a:r>
+              <a:rPr lang="en-US" dirty="0" err="1"/>
+              <a:t>নেওয়া</a:t>
+            </a:r>
+            <a:r>
+              <a:rPr lang="en-US" dirty="0"/>
+              <a:t> </a:t>
+            </a:r>
+            <a:r>
+              <a:rPr lang="en-US" dirty="0" err="1"/>
+              <a:t>গেছে</a:t>
+            </a:r>
+            <a:r>
+              <a:rPr lang="en-US" dirty="0"/>
+              <a:t>।</a:t>
+            </a:r>
+          </a:p>
+        </p:txBody>
+      </p:sp>
+    </p:spTree>
+    <p:extLst>
+      <p:ext uri="{BB962C8B-B14F-4D97-AF65-F5344CB8AC3E}">
+        <p14:creationId xmlns:p14="http://schemas.microsoft.com/office/powerpoint/2010/main" val="3802872350"/>
+      </p:ext>
+    </p:extLst>
+  </p:cSld>
+  <p:clrMapOvr>
+    <a:masterClrMapping/>
+  </p:clrMapOvr>
+</p:sld>
+</file>
+
+<file path=ppt/slides/slide16.xml><?xml version="1.0" encoding="utf-8"?>
 <p:sld xmlns:a="http://schemas.openxmlformats.org/drawingml/2006/main" xmlns:r="http://schemas.openxmlformats.org/officeDocument/2006/relationships" xmlns:p="http://schemas.openxmlformats.org/presentationml/2006/main">
   <p:cSld>
     <p:spTree>
@@ -3587,7 +4387,1225 @@
     </p:spTree>
     <p:extLst>
       <p:ext uri="{BB962C8B-B14F-4D97-AF65-F5344CB8AC3E}">
-        <p14:creationId xmlns="" xmlns:p14="http://schemas.microsoft.com/office/powerpoint/2010/main" val="2554770859"/>
+        <p14:creationId xmlns:p14="http://schemas.microsoft.com/office/powerpoint/2010/main" val="2554770859"/>
+      </p:ext>
+    </p:extLst>
+  </p:cSld>
+  <p:clrMapOvr>
+    <a:masterClrMapping/>
+  </p:clrMapOvr>
+</p:sld>
+</file>
+
+<file path=ppt/slides/slide17.xml><?xml version="1.0" encoding="utf-8"?>
+<p:sld xmlns:a="http://schemas.openxmlformats.org/drawingml/2006/main" xmlns:r="http://schemas.openxmlformats.org/officeDocument/2006/relationships" xmlns:p="http://schemas.openxmlformats.org/presentationml/2006/main">
+  <p:cSld>
+    <p:spTree>
+      <p:nvGrpSpPr>
+        <p:cNvPr id="1" name=""/>
+        <p:cNvGrpSpPr/>
+        <p:nvPr/>
+      </p:nvGrpSpPr>
+      <p:grpSpPr>
+        <a:xfrm>
+          <a:off x="0" y="0"/>
+          <a:ext cx="0" cy="0"/>
+          <a:chOff x="0" y="0"/>
+          <a:chExt cx="0" cy="0"/>
+        </a:xfrm>
+      </p:grpSpPr>
+      <p:sp>
+        <p:nvSpPr>
+          <p:cNvPr id="2" name="Title 1">
+            <a:extLst>
+              <a:ext uri="{FF2B5EF4-FFF2-40B4-BE49-F238E27FC236}">
+                <a16:creationId xmlns:a16="http://schemas.microsoft.com/office/drawing/2014/main" id="{517B89CA-8759-377C-46AF-174EE5F57F4C}"/>
+              </a:ext>
+            </a:extLst>
+          </p:cNvPr>
+          <p:cNvSpPr>
+            <a:spLocks noGrp="1"/>
+          </p:cNvSpPr>
+          <p:nvPr>
+            <p:ph type="title"/>
+          </p:nvPr>
+        </p:nvSpPr>
+        <p:spPr/>
+        <p:txBody>
+          <a:bodyPr/>
+          <a:lstStyle/>
+          <a:p>
+            <a:r>
+              <a:rPr lang="en-US" dirty="0"/>
+              <a:t>Real-World CS Application: Automated Malware Detection</a:t>
+            </a:r>
+          </a:p>
+        </p:txBody>
+      </p:sp>
+      <p:sp>
+        <p:nvSpPr>
+          <p:cNvPr id="3" name="Content Placeholder 2">
+            <a:extLst>
+              <a:ext uri="{FF2B5EF4-FFF2-40B4-BE49-F238E27FC236}">
+                <a16:creationId xmlns:a16="http://schemas.microsoft.com/office/drawing/2014/main" id="{4F843B08-6CD9-9920-AFB3-CCF8D5EFF81F}"/>
+              </a:ext>
+            </a:extLst>
+          </p:cNvPr>
+          <p:cNvSpPr>
+            <a:spLocks noGrp="1"/>
+          </p:cNvSpPr>
+          <p:nvPr>
+            <p:ph idx="1"/>
+          </p:nvPr>
+        </p:nvSpPr>
+        <p:spPr/>
+        <p:txBody>
+          <a:bodyPr/>
+          <a:lstStyle/>
+          <a:p>
+            <a:r>
+              <a:rPr lang="en-US" b="1" dirty="0"/>
+              <a:t>Problem Statement</a:t>
+            </a:r>
+          </a:p>
+          <a:p>
+            <a:pPr lvl="1"/>
+            <a:r>
+              <a:rPr lang="en-US" dirty="0"/>
+              <a:t>An Antivirus Endpoint Protection Engine intercepts an unknown executable file (unknown_process.exe). Before allowing it to run, the system must classify it as </a:t>
+            </a:r>
+            <a:r>
+              <a:rPr lang="en-US" dirty="0">
+                <a:solidFill>
+                  <a:srgbClr val="FF0000"/>
+                </a:solidFill>
+              </a:rPr>
+              <a:t>either </a:t>
+            </a:r>
+            <a:r>
+              <a:rPr lang="en-US" b="1" dirty="0">
+                <a:solidFill>
+                  <a:srgbClr val="FF0000"/>
+                </a:solidFill>
+              </a:rPr>
+              <a:t>Benign</a:t>
+            </a:r>
+            <a:r>
+              <a:rPr lang="en-US" dirty="0">
+                <a:solidFill>
+                  <a:srgbClr val="FF0000"/>
+                </a:solidFill>
+              </a:rPr>
+              <a:t> (Safe) or </a:t>
+            </a:r>
+            <a:r>
+              <a:rPr lang="en-US" b="1" dirty="0">
+                <a:solidFill>
+                  <a:srgbClr val="FF0000"/>
+                </a:solidFill>
+              </a:rPr>
+              <a:t>Malware</a:t>
+            </a:r>
+            <a:r>
+              <a:rPr lang="en-US" dirty="0">
+                <a:solidFill>
+                  <a:srgbClr val="FF0000"/>
+                </a:solidFill>
+              </a:rPr>
+              <a:t> (Malicious) based on its behavioral telemetry.</a:t>
+            </a:r>
+          </a:p>
+          <a:p>
+            <a:endParaRPr lang="en-US" dirty="0"/>
+          </a:p>
+        </p:txBody>
+      </p:sp>
+    </p:spTree>
+    <p:extLst>
+      <p:ext uri="{BB962C8B-B14F-4D97-AF65-F5344CB8AC3E}">
+        <p14:creationId xmlns:p14="http://schemas.microsoft.com/office/powerpoint/2010/main" val="385055534"/>
+      </p:ext>
+    </p:extLst>
+  </p:cSld>
+  <p:clrMapOvr>
+    <a:masterClrMapping/>
+  </p:clrMapOvr>
+</p:sld>
+</file>
+
+<file path=ppt/slides/slide18.xml><?xml version="1.0" encoding="utf-8"?>
+<p:sld xmlns:a="http://schemas.openxmlformats.org/drawingml/2006/main" xmlns:r="http://schemas.openxmlformats.org/officeDocument/2006/relationships" xmlns:p="http://schemas.openxmlformats.org/presentationml/2006/main">
+  <p:cSld>
+    <p:spTree>
+      <p:nvGrpSpPr>
+        <p:cNvPr id="1" name=""/>
+        <p:cNvGrpSpPr/>
+        <p:nvPr/>
+      </p:nvGrpSpPr>
+      <p:grpSpPr>
+        <a:xfrm>
+          <a:off x="0" y="0"/>
+          <a:ext cx="0" cy="0"/>
+          <a:chOff x="0" y="0"/>
+          <a:chExt cx="0" cy="0"/>
+        </a:xfrm>
+      </p:grpSpPr>
+      <p:sp>
+        <p:nvSpPr>
+          <p:cNvPr id="2" name="Title 1">
+            <a:extLst>
+              <a:ext uri="{FF2B5EF4-FFF2-40B4-BE49-F238E27FC236}">
+                <a16:creationId xmlns:a16="http://schemas.microsoft.com/office/drawing/2014/main" id="{E8AFC47E-EE12-D9FC-7ABD-F390FA6450ED}"/>
+              </a:ext>
+            </a:extLst>
+          </p:cNvPr>
+          <p:cNvSpPr>
+            <a:spLocks noGrp="1"/>
+          </p:cNvSpPr>
+          <p:nvPr>
+            <p:ph type="title"/>
+          </p:nvPr>
+        </p:nvSpPr>
+        <p:spPr/>
+        <p:txBody>
+          <a:bodyPr/>
+          <a:lstStyle/>
+          <a:p>
+            <a:endParaRPr lang="en-US"/>
+          </a:p>
+        </p:txBody>
+      </p:sp>
+      <p:graphicFrame>
+        <p:nvGraphicFramePr>
+          <p:cNvPr id="6" name="Content Placeholder 5">
+            <a:extLst>
+              <a:ext uri="{FF2B5EF4-FFF2-40B4-BE49-F238E27FC236}">
+                <a16:creationId xmlns:a16="http://schemas.microsoft.com/office/drawing/2014/main" id="{E90EAF21-8AE0-B0C1-5E33-025E1433AD26}"/>
+              </a:ext>
+            </a:extLst>
+          </p:cNvPr>
+          <p:cNvGraphicFramePr>
+            <a:graphicFrameLocks noGrp="1"/>
+          </p:cNvGraphicFramePr>
+          <p:nvPr>
+            <p:ph idx="1"/>
+          </p:nvPr>
+        </p:nvGraphicFramePr>
+        <p:xfrm>
+          <a:off x="838200" y="2987261"/>
+          <a:ext cx="10515600" cy="2023872"/>
+        </p:xfrm>
+        <a:graphic>
+          <a:graphicData uri="http://schemas.openxmlformats.org/drawingml/2006/table">
+            <a:tbl>
+              <a:tblPr firstRow="1" firstCol="1" bandRow="1">
+                <a:tableStyleId>{5C22544A-7EE6-4342-B048-85BDC9FD1C3A}</a:tableStyleId>
+              </a:tblPr>
+              <a:tblGrid>
+                <a:gridCol w="2628900">
+                  <a:extLst>
+                    <a:ext uri="{9D8B030D-6E8A-4147-A177-3AD203B41FA5}">
+                      <a16:colId xmlns:a16="http://schemas.microsoft.com/office/drawing/2014/main" val="2689175807"/>
+                    </a:ext>
+                  </a:extLst>
+                </a:gridCol>
+                <a:gridCol w="2628900">
+                  <a:extLst>
+                    <a:ext uri="{9D8B030D-6E8A-4147-A177-3AD203B41FA5}">
+                      <a16:colId xmlns:a16="http://schemas.microsoft.com/office/drawing/2014/main" val="2925883130"/>
+                    </a:ext>
+                  </a:extLst>
+                </a:gridCol>
+                <a:gridCol w="2628900">
+                  <a:extLst>
+                    <a:ext uri="{9D8B030D-6E8A-4147-A177-3AD203B41FA5}">
+                      <a16:colId xmlns:a16="http://schemas.microsoft.com/office/drawing/2014/main" val="679982421"/>
+                    </a:ext>
+                  </a:extLst>
+                </a:gridCol>
+                <a:gridCol w="2628900">
+                  <a:extLst>
+                    <a:ext uri="{9D8B030D-6E8A-4147-A177-3AD203B41FA5}">
+                      <a16:colId xmlns:a16="http://schemas.microsoft.com/office/drawing/2014/main" val="509295811"/>
+                    </a:ext>
+                  </a:extLst>
+                </a:gridCol>
+              </a:tblGrid>
+              <a:tr h="200025">
+                <a:tc>
+                  <a:txBody>
+                    <a:bodyPr/>
+                    <a:lstStyle/>
+                    <a:p>
+                      <a:pPr marL="0" marR="0" algn="ctr">
+                        <a:lnSpc>
+                          <a:spcPct val="115000"/>
+                        </a:lnSpc>
+                        <a:spcAft>
+                          <a:spcPts val="800"/>
+                        </a:spcAft>
+                        <a:buNone/>
+                      </a:pPr>
+                      <a:r>
+                        <a:rPr lang="en-US" sz="1800" kern="100">
+                          <a:effectLst/>
+                        </a:rPr>
+                        <a:t>Executable File</a:t>
+                      </a:r>
+                      <a:endParaRPr lang="en-US" sz="1200" kern="100">
+                        <a:effectLst/>
+                        <a:latin typeface="Aptos" panose="020B0004020202020204" pitchFamily="34" charset="0"/>
+                        <a:ea typeface="Aptos" panose="020B0004020202020204" pitchFamily="34" charset="0"/>
+                        <a:cs typeface="Times New Roman" panose="02020603050405020304" pitchFamily="18" charset="0"/>
+                      </a:endParaRPr>
+                    </a:p>
+                  </a:txBody>
+                  <a:tcPr marL="28575" marR="28575" marT="19050" marB="19050" anchor="ctr"/>
+                </a:tc>
+                <a:tc>
+                  <a:txBody>
+                    <a:bodyPr/>
+                    <a:lstStyle/>
+                    <a:p>
+                      <a:pPr marL="0" marR="0" algn="ctr">
+                        <a:lnSpc>
+                          <a:spcPct val="115000"/>
+                        </a:lnSpc>
+                        <a:spcAft>
+                          <a:spcPts val="800"/>
+                        </a:spcAft>
+                        <a:buNone/>
+                      </a:pPr>
+                      <a:r>
+                        <a:rPr lang="en-US" sz="1800" kern="100">
+                          <a:effectLst/>
+                        </a:rPr>
+                        <a:t>Registry Edits (x1​)</a:t>
+                      </a:r>
+                      <a:endParaRPr lang="en-US" sz="1200" kern="100">
+                        <a:effectLst/>
+                        <a:latin typeface="Aptos" panose="020B0004020202020204" pitchFamily="34" charset="0"/>
+                        <a:ea typeface="Aptos" panose="020B0004020202020204" pitchFamily="34" charset="0"/>
+                        <a:cs typeface="Times New Roman" panose="02020603050405020304" pitchFamily="18" charset="0"/>
+                      </a:endParaRPr>
+                    </a:p>
+                  </a:txBody>
+                  <a:tcPr marL="28575" marR="28575" marT="19050" marB="19050" anchor="ctr"/>
+                </a:tc>
+                <a:tc>
+                  <a:txBody>
+                    <a:bodyPr/>
+                    <a:lstStyle/>
+                    <a:p>
+                      <a:pPr marL="0" marR="0" algn="ctr">
+                        <a:lnSpc>
+                          <a:spcPct val="115000"/>
+                        </a:lnSpc>
+                        <a:spcAft>
+                          <a:spcPts val="800"/>
+                        </a:spcAft>
+                        <a:buNone/>
+                      </a:pPr>
+                      <a:r>
+                        <a:rPr lang="en-US" sz="1800" kern="100">
+                          <a:effectLst/>
+                        </a:rPr>
+                        <a:t>Network Conns (x2​)</a:t>
+                      </a:r>
+                      <a:endParaRPr lang="en-US" sz="1200" kern="100">
+                        <a:effectLst/>
+                        <a:latin typeface="Aptos" panose="020B0004020202020204" pitchFamily="34" charset="0"/>
+                        <a:ea typeface="Aptos" panose="020B0004020202020204" pitchFamily="34" charset="0"/>
+                        <a:cs typeface="Times New Roman" panose="02020603050405020304" pitchFamily="18" charset="0"/>
+                      </a:endParaRPr>
+                    </a:p>
+                  </a:txBody>
+                  <a:tcPr marL="28575" marR="28575" marT="19050" marB="19050" anchor="ctr"/>
+                </a:tc>
+                <a:tc>
+                  <a:txBody>
+                    <a:bodyPr/>
+                    <a:lstStyle/>
+                    <a:p>
+                      <a:pPr marL="0" marR="0" algn="ctr">
+                        <a:lnSpc>
+                          <a:spcPct val="115000"/>
+                        </a:lnSpc>
+                        <a:spcAft>
+                          <a:spcPts val="800"/>
+                        </a:spcAft>
+                        <a:buNone/>
+                      </a:pPr>
+                      <a:r>
+                        <a:rPr lang="en-US" sz="1800" kern="100">
+                          <a:effectLst/>
+                        </a:rPr>
+                        <a:t>Label / Class (Y)</a:t>
+                      </a:r>
+                      <a:endParaRPr lang="en-US" sz="1200" kern="100">
+                        <a:effectLst/>
+                        <a:latin typeface="Aptos" panose="020B0004020202020204" pitchFamily="34" charset="0"/>
+                        <a:ea typeface="Aptos" panose="020B0004020202020204" pitchFamily="34" charset="0"/>
+                        <a:cs typeface="Times New Roman" panose="02020603050405020304" pitchFamily="18" charset="0"/>
+                      </a:endParaRPr>
+                    </a:p>
+                  </a:txBody>
+                  <a:tcPr marL="28575" marR="28575" marT="19050" marB="19050" anchor="ctr"/>
+                </a:tc>
+                <a:extLst>
+                  <a:ext uri="{0D108BD9-81ED-4DB2-BD59-A6C34878D82A}">
+                    <a16:rowId xmlns:a16="http://schemas.microsoft.com/office/drawing/2014/main" val="3562208214"/>
+                  </a:ext>
+                </a:extLst>
+              </a:tr>
+              <a:tr h="200025">
+                <a:tc>
+                  <a:txBody>
+                    <a:bodyPr/>
+                    <a:lstStyle/>
+                    <a:p>
+                      <a:pPr marL="0" marR="0" algn="ctr">
+                        <a:lnSpc>
+                          <a:spcPct val="115000"/>
+                        </a:lnSpc>
+                        <a:spcAft>
+                          <a:spcPts val="800"/>
+                        </a:spcAft>
+                        <a:buNone/>
+                      </a:pPr>
+                      <a:r>
+                        <a:rPr lang="en-US" sz="1800" kern="100">
+                          <a:effectLst/>
+                        </a:rPr>
+                        <a:t>chrome.exe</a:t>
+                      </a:r>
+                      <a:endParaRPr lang="en-US" sz="1200" kern="100">
+                        <a:effectLst/>
+                        <a:latin typeface="Aptos" panose="020B0004020202020204" pitchFamily="34" charset="0"/>
+                        <a:ea typeface="Aptos" panose="020B0004020202020204" pitchFamily="34" charset="0"/>
+                        <a:cs typeface="Times New Roman" panose="02020603050405020304" pitchFamily="18" charset="0"/>
+                      </a:endParaRPr>
+                    </a:p>
+                  </a:txBody>
+                  <a:tcPr marL="28575" marR="28575" marT="19050" marB="19050" anchor="ctr"/>
+                </a:tc>
+                <a:tc>
+                  <a:txBody>
+                    <a:bodyPr/>
+                    <a:lstStyle/>
+                    <a:p>
+                      <a:pPr marL="0" marR="0" algn="ctr">
+                        <a:lnSpc>
+                          <a:spcPct val="115000"/>
+                        </a:lnSpc>
+                        <a:spcAft>
+                          <a:spcPts val="800"/>
+                        </a:spcAft>
+                        <a:buNone/>
+                      </a:pPr>
+                      <a:r>
+                        <a:rPr lang="en-US" sz="1800" kern="100">
+                          <a:effectLst/>
+                        </a:rPr>
+                        <a:t>2</a:t>
+                      </a:r>
+                      <a:endParaRPr lang="en-US" sz="1200" kern="100">
+                        <a:effectLst/>
+                        <a:latin typeface="Aptos" panose="020B0004020202020204" pitchFamily="34" charset="0"/>
+                        <a:ea typeface="Aptos" panose="020B0004020202020204" pitchFamily="34" charset="0"/>
+                        <a:cs typeface="Times New Roman" panose="02020603050405020304" pitchFamily="18" charset="0"/>
+                      </a:endParaRPr>
+                    </a:p>
+                  </a:txBody>
+                  <a:tcPr marL="28575" marR="28575" marT="19050" marB="19050" anchor="ctr"/>
+                </a:tc>
+                <a:tc>
+                  <a:txBody>
+                    <a:bodyPr/>
+                    <a:lstStyle/>
+                    <a:p>
+                      <a:pPr marL="0" marR="0" algn="ctr">
+                        <a:lnSpc>
+                          <a:spcPct val="115000"/>
+                        </a:lnSpc>
+                        <a:spcAft>
+                          <a:spcPts val="800"/>
+                        </a:spcAft>
+                        <a:buNone/>
+                      </a:pPr>
+                      <a:r>
+                        <a:rPr lang="en-US" sz="1800" kern="100">
+                          <a:effectLst/>
+                        </a:rPr>
+                        <a:t>12</a:t>
+                      </a:r>
+                      <a:endParaRPr lang="en-US" sz="1200" kern="100">
+                        <a:effectLst/>
+                        <a:latin typeface="Aptos" panose="020B0004020202020204" pitchFamily="34" charset="0"/>
+                        <a:ea typeface="Aptos" panose="020B0004020202020204" pitchFamily="34" charset="0"/>
+                        <a:cs typeface="Times New Roman" panose="02020603050405020304" pitchFamily="18" charset="0"/>
+                      </a:endParaRPr>
+                    </a:p>
+                  </a:txBody>
+                  <a:tcPr marL="28575" marR="28575" marT="19050" marB="19050" anchor="ctr"/>
+                </a:tc>
+                <a:tc>
+                  <a:txBody>
+                    <a:bodyPr/>
+                    <a:lstStyle/>
+                    <a:p>
+                      <a:pPr marL="0" marR="0" algn="ctr">
+                        <a:lnSpc>
+                          <a:spcPct val="115000"/>
+                        </a:lnSpc>
+                        <a:spcAft>
+                          <a:spcPts val="800"/>
+                        </a:spcAft>
+                        <a:buNone/>
+                      </a:pPr>
+                      <a:r>
+                        <a:rPr lang="en-US" sz="1800" kern="100">
+                          <a:effectLst/>
+                        </a:rPr>
+                        <a:t>Benign</a:t>
+                      </a:r>
+                      <a:endParaRPr lang="en-US" sz="1200" kern="100">
+                        <a:effectLst/>
+                        <a:latin typeface="Aptos" panose="020B0004020202020204" pitchFamily="34" charset="0"/>
+                        <a:ea typeface="Aptos" panose="020B0004020202020204" pitchFamily="34" charset="0"/>
+                        <a:cs typeface="Times New Roman" panose="02020603050405020304" pitchFamily="18" charset="0"/>
+                      </a:endParaRPr>
+                    </a:p>
+                  </a:txBody>
+                  <a:tcPr marL="28575" marR="28575" marT="19050" marB="19050" anchor="ctr"/>
+                </a:tc>
+                <a:extLst>
+                  <a:ext uri="{0D108BD9-81ED-4DB2-BD59-A6C34878D82A}">
+                    <a16:rowId xmlns:a16="http://schemas.microsoft.com/office/drawing/2014/main" val="2016520710"/>
+                  </a:ext>
+                </a:extLst>
+              </a:tr>
+              <a:tr h="200025">
+                <a:tc>
+                  <a:txBody>
+                    <a:bodyPr/>
+                    <a:lstStyle/>
+                    <a:p>
+                      <a:pPr marL="0" marR="0" algn="ctr">
+                        <a:lnSpc>
+                          <a:spcPct val="115000"/>
+                        </a:lnSpc>
+                        <a:spcAft>
+                          <a:spcPts val="800"/>
+                        </a:spcAft>
+                        <a:buNone/>
+                      </a:pPr>
+                      <a:r>
+                        <a:rPr lang="en-US" sz="1800" kern="100">
+                          <a:effectLst/>
+                        </a:rPr>
+                        <a:t>vscode.exe</a:t>
+                      </a:r>
+                      <a:endParaRPr lang="en-US" sz="1200" kern="100">
+                        <a:effectLst/>
+                        <a:latin typeface="Aptos" panose="020B0004020202020204" pitchFamily="34" charset="0"/>
+                        <a:ea typeface="Aptos" panose="020B0004020202020204" pitchFamily="34" charset="0"/>
+                        <a:cs typeface="Times New Roman" panose="02020603050405020304" pitchFamily="18" charset="0"/>
+                      </a:endParaRPr>
+                    </a:p>
+                  </a:txBody>
+                  <a:tcPr marL="28575" marR="28575" marT="19050" marB="19050" anchor="ctr"/>
+                </a:tc>
+                <a:tc>
+                  <a:txBody>
+                    <a:bodyPr/>
+                    <a:lstStyle/>
+                    <a:p>
+                      <a:pPr marL="0" marR="0" algn="ctr">
+                        <a:lnSpc>
+                          <a:spcPct val="115000"/>
+                        </a:lnSpc>
+                        <a:spcAft>
+                          <a:spcPts val="800"/>
+                        </a:spcAft>
+                        <a:buNone/>
+                      </a:pPr>
+                      <a:r>
+                        <a:rPr lang="en-US" sz="1800" kern="100">
+                          <a:effectLst/>
+                        </a:rPr>
+                        <a:t>3</a:t>
+                      </a:r>
+                      <a:endParaRPr lang="en-US" sz="1200" kern="100">
+                        <a:effectLst/>
+                        <a:latin typeface="Aptos" panose="020B0004020202020204" pitchFamily="34" charset="0"/>
+                        <a:ea typeface="Aptos" panose="020B0004020202020204" pitchFamily="34" charset="0"/>
+                        <a:cs typeface="Times New Roman" panose="02020603050405020304" pitchFamily="18" charset="0"/>
+                      </a:endParaRPr>
+                    </a:p>
+                  </a:txBody>
+                  <a:tcPr marL="28575" marR="28575" marT="19050" marB="19050" anchor="ctr"/>
+                </a:tc>
+                <a:tc>
+                  <a:txBody>
+                    <a:bodyPr/>
+                    <a:lstStyle/>
+                    <a:p>
+                      <a:pPr marL="0" marR="0" algn="ctr">
+                        <a:lnSpc>
+                          <a:spcPct val="115000"/>
+                        </a:lnSpc>
+                        <a:spcAft>
+                          <a:spcPts val="800"/>
+                        </a:spcAft>
+                        <a:buNone/>
+                      </a:pPr>
+                      <a:r>
+                        <a:rPr lang="en-US" sz="1800" kern="100">
+                          <a:effectLst/>
+                        </a:rPr>
+                        <a:t>5</a:t>
+                      </a:r>
+                      <a:endParaRPr lang="en-US" sz="1200" kern="100">
+                        <a:effectLst/>
+                        <a:latin typeface="Aptos" panose="020B0004020202020204" pitchFamily="34" charset="0"/>
+                        <a:ea typeface="Aptos" panose="020B0004020202020204" pitchFamily="34" charset="0"/>
+                        <a:cs typeface="Times New Roman" panose="02020603050405020304" pitchFamily="18" charset="0"/>
+                      </a:endParaRPr>
+                    </a:p>
+                  </a:txBody>
+                  <a:tcPr marL="28575" marR="28575" marT="19050" marB="19050" anchor="ctr"/>
+                </a:tc>
+                <a:tc>
+                  <a:txBody>
+                    <a:bodyPr/>
+                    <a:lstStyle/>
+                    <a:p>
+                      <a:pPr marL="0" marR="0" algn="ctr">
+                        <a:lnSpc>
+                          <a:spcPct val="115000"/>
+                        </a:lnSpc>
+                        <a:spcAft>
+                          <a:spcPts val="800"/>
+                        </a:spcAft>
+                        <a:buNone/>
+                      </a:pPr>
+                      <a:r>
+                        <a:rPr lang="en-US" sz="1800" kern="100">
+                          <a:effectLst/>
+                        </a:rPr>
+                        <a:t>Benign</a:t>
+                      </a:r>
+                      <a:endParaRPr lang="en-US" sz="1200" kern="100">
+                        <a:effectLst/>
+                        <a:latin typeface="Aptos" panose="020B0004020202020204" pitchFamily="34" charset="0"/>
+                        <a:ea typeface="Aptos" panose="020B0004020202020204" pitchFamily="34" charset="0"/>
+                        <a:cs typeface="Times New Roman" panose="02020603050405020304" pitchFamily="18" charset="0"/>
+                      </a:endParaRPr>
+                    </a:p>
+                  </a:txBody>
+                  <a:tcPr marL="28575" marR="28575" marT="19050" marB="19050" anchor="ctr"/>
+                </a:tc>
+                <a:extLst>
+                  <a:ext uri="{0D108BD9-81ED-4DB2-BD59-A6C34878D82A}">
+                    <a16:rowId xmlns:a16="http://schemas.microsoft.com/office/drawing/2014/main" val="65228041"/>
+                  </a:ext>
+                </a:extLst>
+              </a:tr>
+              <a:tr h="200025">
+                <a:tc>
+                  <a:txBody>
+                    <a:bodyPr/>
+                    <a:lstStyle/>
+                    <a:p>
+                      <a:pPr marL="0" marR="0" algn="ctr">
+                        <a:lnSpc>
+                          <a:spcPct val="115000"/>
+                        </a:lnSpc>
+                        <a:spcAft>
+                          <a:spcPts val="800"/>
+                        </a:spcAft>
+                        <a:buNone/>
+                      </a:pPr>
+                      <a:r>
+                        <a:rPr lang="en-US" sz="1800" kern="100">
+                          <a:effectLst/>
+                        </a:rPr>
+                        <a:t>calc.exe</a:t>
+                      </a:r>
+                      <a:endParaRPr lang="en-US" sz="1200" kern="100">
+                        <a:effectLst/>
+                        <a:latin typeface="Aptos" panose="020B0004020202020204" pitchFamily="34" charset="0"/>
+                        <a:ea typeface="Aptos" panose="020B0004020202020204" pitchFamily="34" charset="0"/>
+                        <a:cs typeface="Times New Roman" panose="02020603050405020304" pitchFamily="18" charset="0"/>
+                      </a:endParaRPr>
+                    </a:p>
+                  </a:txBody>
+                  <a:tcPr marL="28575" marR="28575" marT="19050" marB="19050" anchor="ctr"/>
+                </a:tc>
+                <a:tc>
+                  <a:txBody>
+                    <a:bodyPr/>
+                    <a:lstStyle/>
+                    <a:p>
+                      <a:pPr marL="0" marR="0" algn="ctr">
+                        <a:lnSpc>
+                          <a:spcPct val="115000"/>
+                        </a:lnSpc>
+                        <a:spcAft>
+                          <a:spcPts val="800"/>
+                        </a:spcAft>
+                        <a:buNone/>
+                      </a:pPr>
+                      <a:r>
+                        <a:rPr lang="en-US" sz="1800" kern="100">
+                          <a:effectLst/>
+                        </a:rPr>
+                        <a:t>1</a:t>
+                      </a:r>
+                      <a:endParaRPr lang="en-US" sz="1200" kern="100">
+                        <a:effectLst/>
+                        <a:latin typeface="Aptos" panose="020B0004020202020204" pitchFamily="34" charset="0"/>
+                        <a:ea typeface="Aptos" panose="020B0004020202020204" pitchFamily="34" charset="0"/>
+                        <a:cs typeface="Times New Roman" panose="02020603050405020304" pitchFamily="18" charset="0"/>
+                      </a:endParaRPr>
+                    </a:p>
+                  </a:txBody>
+                  <a:tcPr marL="28575" marR="28575" marT="19050" marB="19050" anchor="ctr"/>
+                </a:tc>
+                <a:tc>
+                  <a:txBody>
+                    <a:bodyPr/>
+                    <a:lstStyle/>
+                    <a:p>
+                      <a:pPr marL="0" marR="0" algn="ctr">
+                        <a:lnSpc>
+                          <a:spcPct val="115000"/>
+                        </a:lnSpc>
+                        <a:spcAft>
+                          <a:spcPts val="800"/>
+                        </a:spcAft>
+                        <a:buNone/>
+                      </a:pPr>
+                      <a:r>
+                        <a:rPr lang="en-US" sz="1800" kern="100">
+                          <a:effectLst/>
+                        </a:rPr>
+                        <a:t>0</a:t>
+                      </a:r>
+                      <a:endParaRPr lang="en-US" sz="1200" kern="100">
+                        <a:effectLst/>
+                        <a:latin typeface="Aptos" panose="020B0004020202020204" pitchFamily="34" charset="0"/>
+                        <a:ea typeface="Aptos" panose="020B0004020202020204" pitchFamily="34" charset="0"/>
+                        <a:cs typeface="Times New Roman" panose="02020603050405020304" pitchFamily="18" charset="0"/>
+                      </a:endParaRPr>
+                    </a:p>
+                  </a:txBody>
+                  <a:tcPr marL="28575" marR="28575" marT="19050" marB="19050" anchor="ctr"/>
+                </a:tc>
+                <a:tc>
+                  <a:txBody>
+                    <a:bodyPr/>
+                    <a:lstStyle/>
+                    <a:p>
+                      <a:pPr marL="0" marR="0" algn="ctr">
+                        <a:lnSpc>
+                          <a:spcPct val="115000"/>
+                        </a:lnSpc>
+                        <a:spcAft>
+                          <a:spcPts val="800"/>
+                        </a:spcAft>
+                        <a:buNone/>
+                      </a:pPr>
+                      <a:r>
+                        <a:rPr lang="en-US" sz="1800" kern="100">
+                          <a:effectLst/>
+                        </a:rPr>
+                        <a:t>Benign</a:t>
+                      </a:r>
+                      <a:endParaRPr lang="en-US" sz="1200" kern="100">
+                        <a:effectLst/>
+                        <a:latin typeface="Aptos" panose="020B0004020202020204" pitchFamily="34" charset="0"/>
+                        <a:ea typeface="Aptos" panose="020B0004020202020204" pitchFamily="34" charset="0"/>
+                        <a:cs typeface="Times New Roman" panose="02020603050405020304" pitchFamily="18" charset="0"/>
+                      </a:endParaRPr>
+                    </a:p>
+                  </a:txBody>
+                  <a:tcPr marL="28575" marR="28575" marT="19050" marB="19050" anchor="ctr"/>
+                </a:tc>
+                <a:extLst>
+                  <a:ext uri="{0D108BD9-81ED-4DB2-BD59-A6C34878D82A}">
+                    <a16:rowId xmlns:a16="http://schemas.microsoft.com/office/drawing/2014/main" val="840849204"/>
+                  </a:ext>
+                </a:extLst>
+              </a:tr>
+              <a:tr h="200025">
+                <a:tc>
+                  <a:txBody>
+                    <a:bodyPr/>
+                    <a:lstStyle/>
+                    <a:p>
+                      <a:pPr marL="0" marR="0" algn="ctr">
+                        <a:lnSpc>
+                          <a:spcPct val="115000"/>
+                        </a:lnSpc>
+                        <a:spcAft>
+                          <a:spcPts val="800"/>
+                        </a:spcAft>
+                        <a:buNone/>
+                      </a:pPr>
+                      <a:r>
+                        <a:rPr lang="en-US" sz="1800" kern="100">
+                          <a:effectLst/>
+                        </a:rPr>
+                        <a:t>trojan_x.exe</a:t>
+                      </a:r>
+                      <a:endParaRPr lang="en-US" sz="1200" kern="100">
+                        <a:effectLst/>
+                        <a:latin typeface="Aptos" panose="020B0004020202020204" pitchFamily="34" charset="0"/>
+                        <a:ea typeface="Aptos" panose="020B0004020202020204" pitchFamily="34" charset="0"/>
+                        <a:cs typeface="Times New Roman" panose="02020603050405020304" pitchFamily="18" charset="0"/>
+                      </a:endParaRPr>
+                    </a:p>
+                  </a:txBody>
+                  <a:tcPr marL="28575" marR="28575" marT="19050" marB="19050" anchor="ctr"/>
+                </a:tc>
+                <a:tc>
+                  <a:txBody>
+                    <a:bodyPr/>
+                    <a:lstStyle/>
+                    <a:p>
+                      <a:pPr marL="0" marR="0" algn="ctr">
+                        <a:lnSpc>
+                          <a:spcPct val="115000"/>
+                        </a:lnSpc>
+                        <a:spcAft>
+                          <a:spcPts val="800"/>
+                        </a:spcAft>
+                        <a:buNone/>
+                      </a:pPr>
+                      <a:r>
+                        <a:rPr lang="en-US" sz="1800" kern="100">
+                          <a:effectLst/>
+                        </a:rPr>
+                        <a:t>15</a:t>
+                      </a:r>
+                      <a:endParaRPr lang="en-US" sz="1200" kern="100">
+                        <a:effectLst/>
+                        <a:latin typeface="Aptos" panose="020B0004020202020204" pitchFamily="34" charset="0"/>
+                        <a:ea typeface="Aptos" panose="020B0004020202020204" pitchFamily="34" charset="0"/>
+                        <a:cs typeface="Times New Roman" panose="02020603050405020304" pitchFamily="18" charset="0"/>
+                      </a:endParaRPr>
+                    </a:p>
+                  </a:txBody>
+                  <a:tcPr marL="28575" marR="28575" marT="19050" marB="19050" anchor="ctr"/>
+                </a:tc>
+                <a:tc>
+                  <a:txBody>
+                    <a:bodyPr/>
+                    <a:lstStyle/>
+                    <a:p>
+                      <a:pPr marL="0" marR="0" algn="ctr">
+                        <a:lnSpc>
+                          <a:spcPct val="115000"/>
+                        </a:lnSpc>
+                        <a:spcAft>
+                          <a:spcPts val="800"/>
+                        </a:spcAft>
+                        <a:buNone/>
+                      </a:pPr>
+                      <a:r>
+                        <a:rPr lang="en-US" sz="1800" kern="100">
+                          <a:effectLst/>
+                        </a:rPr>
+                        <a:t>18</a:t>
+                      </a:r>
+                      <a:endParaRPr lang="en-US" sz="1200" kern="100">
+                        <a:effectLst/>
+                        <a:latin typeface="Aptos" panose="020B0004020202020204" pitchFamily="34" charset="0"/>
+                        <a:ea typeface="Aptos" panose="020B0004020202020204" pitchFamily="34" charset="0"/>
+                        <a:cs typeface="Times New Roman" panose="02020603050405020304" pitchFamily="18" charset="0"/>
+                      </a:endParaRPr>
+                    </a:p>
+                  </a:txBody>
+                  <a:tcPr marL="28575" marR="28575" marT="19050" marB="19050" anchor="ctr"/>
+                </a:tc>
+                <a:tc>
+                  <a:txBody>
+                    <a:bodyPr/>
+                    <a:lstStyle/>
+                    <a:p>
+                      <a:pPr marL="0" marR="0" algn="ctr">
+                        <a:lnSpc>
+                          <a:spcPct val="115000"/>
+                        </a:lnSpc>
+                        <a:spcAft>
+                          <a:spcPts val="800"/>
+                        </a:spcAft>
+                        <a:buNone/>
+                      </a:pPr>
+                      <a:r>
+                        <a:rPr lang="en-US" sz="1800" kern="100">
+                          <a:effectLst/>
+                        </a:rPr>
+                        <a:t>Malware</a:t>
+                      </a:r>
+                      <a:endParaRPr lang="en-US" sz="1200" kern="100">
+                        <a:effectLst/>
+                        <a:latin typeface="Aptos" panose="020B0004020202020204" pitchFamily="34" charset="0"/>
+                        <a:ea typeface="Aptos" panose="020B0004020202020204" pitchFamily="34" charset="0"/>
+                        <a:cs typeface="Times New Roman" panose="02020603050405020304" pitchFamily="18" charset="0"/>
+                      </a:endParaRPr>
+                    </a:p>
+                  </a:txBody>
+                  <a:tcPr marL="28575" marR="28575" marT="19050" marB="19050" anchor="ctr"/>
+                </a:tc>
+                <a:extLst>
+                  <a:ext uri="{0D108BD9-81ED-4DB2-BD59-A6C34878D82A}">
+                    <a16:rowId xmlns:a16="http://schemas.microsoft.com/office/drawing/2014/main" val="895645380"/>
+                  </a:ext>
+                </a:extLst>
+              </a:tr>
+              <a:tr h="200025">
+                <a:tc>
+                  <a:txBody>
+                    <a:bodyPr/>
+                    <a:lstStyle/>
+                    <a:p>
+                      <a:pPr marL="0" marR="0" algn="ctr">
+                        <a:lnSpc>
+                          <a:spcPct val="115000"/>
+                        </a:lnSpc>
+                        <a:spcAft>
+                          <a:spcPts val="800"/>
+                        </a:spcAft>
+                        <a:buNone/>
+                      </a:pPr>
+                      <a:r>
+                        <a:rPr lang="en-US" sz="1800" kern="100">
+                          <a:effectLst/>
+                        </a:rPr>
+                        <a:t>ransom.exe</a:t>
+                      </a:r>
+                      <a:endParaRPr lang="en-US" sz="1200" kern="100">
+                        <a:effectLst/>
+                        <a:latin typeface="Aptos" panose="020B0004020202020204" pitchFamily="34" charset="0"/>
+                        <a:ea typeface="Aptos" panose="020B0004020202020204" pitchFamily="34" charset="0"/>
+                        <a:cs typeface="Times New Roman" panose="02020603050405020304" pitchFamily="18" charset="0"/>
+                      </a:endParaRPr>
+                    </a:p>
+                  </a:txBody>
+                  <a:tcPr marL="28575" marR="28575" marT="19050" marB="19050" anchor="ctr"/>
+                </a:tc>
+                <a:tc>
+                  <a:txBody>
+                    <a:bodyPr/>
+                    <a:lstStyle/>
+                    <a:p>
+                      <a:pPr marL="0" marR="0" algn="ctr">
+                        <a:lnSpc>
+                          <a:spcPct val="115000"/>
+                        </a:lnSpc>
+                        <a:spcAft>
+                          <a:spcPts val="800"/>
+                        </a:spcAft>
+                        <a:buNone/>
+                      </a:pPr>
+                      <a:r>
+                        <a:rPr lang="en-US" sz="1800" kern="100">
+                          <a:effectLst/>
+                        </a:rPr>
+                        <a:t>18</a:t>
+                      </a:r>
+                      <a:endParaRPr lang="en-US" sz="1200" kern="100">
+                        <a:effectLst/>
+                        <a:latin typeface="Aptos" panose="020B0004020202020204" pitchFamily="34" charset="0"/>
+                        <a:ea typeface="Aptos" panose="020B0004020202020204" pitchFamily="34" charset="0"/>
+                        <a:cs typeface="Times New Roman" panose="02020603050405020304" pitchFamily="18" charset="0"/>
+                      </a:endParaRPr>
+                    </a:p>
+                  </a:txBody>
+                  <a:tcPr marL="28575" marR="28575" marT="19050" marB="19050" anchor="ctr"/>
+                </a:tc>
+                <a:tc>
+                  <a:txBody>
+                    <a:bodyPr/>
+                    <a:lstStyle/>
+                    <a:p>
+                      <a:pPr marL="0" marR="0" algn="ctr">
+                        <a:lnSpc>
+                          <a:spcPct val="115000"/>
+                        </a:lnSpc>
+                        <a:spcAft>
+                          <a:spcPts val="800"/>
+                        </a:spcAft>
+                        <a:buNone/>
+                      </a:pPr>
+                      <a:r>
+                        <a:rPr lang="en-US" sz="1800" kern="100">
+                          <a:effectLst/>
+                        </a:rPr>
+                        <a:t>14</a:t>
+                      </a:r>
+                      <a:endParaRPr lang="en-US" sz="1200" kern="100">
+                        <a:effectLst/>
+                        <a:latin typeface="Aptos" panose="020B0004020202020204" pitchFamily="34" charset="0"/>
+                        <a:ea typeface="Aptos" panose="020B0004020202020204" pitchFamily="34" charset="0"/>
+                        <a:cs typeface="Times New Roman" panose="02020603050405020304" pitchFamily="18" charset="0"/>
+                      </a:endParaRPr>
+                    </a:p>
+                  </a:txBody>
+                  <a:tcPr marL="28575" marR="28575" marT="19050" marB="19050" anchor="ctr"/>
+                </a:tc>
+                <a:tc>
+                  <a:txBody>
+                    <a:bodyPr/>
+                    <a:lstStyle/>
+                    <a:p>
+                      <a:pPr marL="0" marR="0" algn="ctr">
+                        <a:lnSpc>
+                          <a:spcPct val="115000"/>
+                        </a:lnSpc>
+                        <a:spcAft>
+                          <a:spcPts val="800"/>
+                        </a:spcAft>
+                        <a:buNone/>
+                      </a:pPr>
+                      <a:r>
+                        <a:rPr lang="en-US" sz="1800" kern="100" dirty="0">
+                          <a:effectLst/>
+                        </a:rPr>
+                        <a:t>Malware</a:t>
+                      </a:r>
+                      <a:endParaRPr lang="en-US" sz="1200" kern="100" dirty="0">
+                        <a:effectLst/>
+                        <a:latin typeface="Aptos" panose="020B0004020202020204" pitchFamily="34" charset="0"/>
+                        <a:ea typeface="Aptos" panose="020B0004020202020204" pitchFamily="34" charset="0"/>
+                        <a:cs typeface="Times New Roman" panose="02020603050405020304" pitchFamily="18" charset="0"/>
+                      </a:endParaRPr>
+                    </a:p>
+                  </a:txBody>
+                  <a:tcPr marL="28575" marR="28575" marT="19050" marB="19050" anchor="ctr"/>
+                </a:tc>
+                <a:extLst>
+                  <a:ext uri="{0D108BD9-81ED-4DB2-BD59-A6C34878D82A}">
+                    <a16:rowId xmlns:a16="http://schemas.microsoft.com/office/drawing/2014/main" val="1643721641"/>
+                  </a:ext>
+                </a:extLst>
+              </a:tr>
+            </a:tbl>
+          </a:graphicData>
+        </a:graphic>
+      </p:graphicFrame>
+      <p:pic>
+        <p:nvPicPr>
+          <p:cNvPr id="5" name="Picture 4">
+            <a:extLst>
+              <a:ext uri="{FF2B5EF4-FFF2-40B4-BE49-F238E27FC236}">
+                <a16:creationId xmlns:a16="http://schemas.microsoft.com/office/drawing/2014/main" id="{B9699FAE-3C63-AD46-1047-B026DB0D4CB4}"/>
+              </a:ext>
+            </a:extLst>
+          </p:cNvPr>
+          <p:cNvPicPr>
+            <a:picLocks noChangeAspect="1"/>
+          </p:cNvPicPr>
+          <p:nvPr/>
+        </p:nvPicPr>
+        <p:blipFill>
+          <a:blip r:embed="rId2"/>
+          <a:stretch>
+            <a:fillRect/>
+          </a:stretch>
+        </p:blipFill>
+        <p:spPr>
+          <a:xfrm>
+            <a:off x="66871" y="8588"/>
+            <a:ext cx="8729596" cy="2137453"/>
+          </a:xfrm>
+          <a:prstGeom prst="rect">
+            <a:avLst/>
+          </a:prstGeom>
+        </p:spPr>
+      </p:pic>
+      <p:sp>
+        <p:nvSpPr>
+          <p:cNvPr id="8" name="TextBox 7">
+            <a:extLst>
+              <a:ext uri="{FF2B5EF4-FFF2-40B4-BE49-F238E27FC236}">
+                <a16:creationId xmlns:a16="http://schemas.microsoft.com/office/drawing/2014/main" id="{BC52F3C0-A20C-8969-5995-851260FA6B4E}"/>
+              </a:ext>
+            </a:extLst>
+          </p:cNvPr>
+          <p:cNvSpPr txBox="1"/>
+          <p:nvPr/>
+        </p:nvSpPr>
+        <p:spPr>
+          <a:xfrm>
+            <a:off x="838200" y="2502578"/>
+            <a:ext cx="6824565" cy="369332"/>
+          </a:xfrm>
+          <a:prstGeom prst="rect">
+            <a:avLst/>
+          </a:prstGeom>
+          <a:noFill/>
+        </p:spPr>
+        <p:txBody>
+          <a:bodyPr wrap="square">
+            <a:spAutoFit/>
+          </a:bodyPr>
+          <a:lstStyle/>
+          <a:p>
+            <a:r>
+              <a:rPr lang="en-US" b="1" dirty="0"/>
+              <a:t>Training Dataset (Known Telemetry Vectors):</a:t>
+            </a:r>
+          </a:p>
+        </p:txBody>
+      </p:sp>
+    </p:spTree>
+    <p:extLst>
+      <p:ext uri="{BB962C8B-B14F-4D97-AF65-F5344CB8AC3E}">
+        <p14:creationId xmlns:p14="http://schemas.microsoft.com/office/powerpoint/2010/main" val="812552136"/>
+      </p:ext>
+    </p:extLst>
+  </p:cSld>
+  <p:clrMapOvr>
+    <a:masterClrMapping/>
+  </p:clrMapOvr>
+</p:sld>
+</file>
+
+<file path=ppt/slides/slide19.xml><?xml version="1.0" encoding="utf-8"?>
+<p:sld xmlns:a="http://schemas.openxmlformats.org/drawingml/2006/main" xmlns:r="http://schemas.openxmlformats.org/officeDocument/2006/relationships" xmlns:p="http://schemas.openxmlformats.org/presentationml/2006/main">
+  <p:cSld>
+    <p:spTree>
+      <p:nvGrpSpPr>
+        <p:cNvPr id="1" name=""/>
+        <p:cNvGrpSpPr/>
+        <p:nvPr/>
+      </p:nvGrpSpPr>
+      <p:grpSpPr>
+        <a:xfrm>
+          <a:off x="0" y="0"/>
+          <a:ext cx="0" cy="0"/>
+          <a:chOff x="0" y="0"/>
+          <a:chExt cx="0" cy="0"/>
+        </a:xfrm>
+      </p:grpSpPr>
+      <p:sp>
+        <p:nvSpPr>
+          <p:cNvPr id="2" name="Title 1">
+            <a:extLst>
+              <a:ext uri="{FF2B5EF4-FFF2-40B4-BE49-F238E27FC236}">
+                <a16:creationId xmlns:a16="http://schemas.microsoft.com/office/drawing/2014/main" id="{5FAA3F6F-A77C-17DE-4670-869EA28330BA}"/>
+              </a:ext>
+            </a:extLst>
+          </p:cNvPr>
+          <p:cNvSpPr>
+            <a:spLocks noGrp="1"/>
+          </p:cNvSpPr>
+          <p:nvPr>
+            <p:ph type="title"/>
+          </p:nvPr>
+        </p:nvSpPr>
+        <p:spPr/>
+        <p:txBody>
+          <a:bodyPr/>
+          <a:lstStyle/>
+          <a:p>
+            <a:endParaRPr lang="en-US"/>
+          </a:p>
+        </p:txBody>
+      </p:sp>
+      <p:sp>
+        <p:nvSpPr>
+          <p:cNvPr id="3" name="Content Placeholder 2">
+            <a:extLst>
+              <a:ext uri="{FF2B5EF4-FFF2-40B4-BE49-F238E27FC236}">
+                <a16:creationId xmlns:a16="http://schemas.microsoft.com/office/drawing/2014/main" id="{1BD7802C-F98C-0895-5329-32F609EC883E}"/>
+              </a:ext>
+            </a:extLst>
+          </p:cNvPr>
+          <p:cNvSpPr>
+            <a:spLocks noGrp="1"/>
+          </p:cNvSpPr>
+          <p:nvPr>
+            <p:ph idx="1"/>
+          </p:nvPr>
+        </p:nvSpPr>
+        <p:spPr/>
+        <p:txBody>
+          <a:bodyPr/>
+          <a:lstStyle/>
+          <a:p>
+            <a:endParaRPr lang="en-US"/>
+          </a:p>
+        </p:txBody>
+      </p:sp>
+      <p:pic>
+        <p:nvPicPr>
+          <p:cNvPr id="5" name="Picture 4">
+            <a:extLst>
+              <a:ext uri="{FF2B5EF4-FFF2-40B4-BE49-F238E27FC236}">
+                <a16:creationId xmlns:a16="http://schemas.microsoft.com/office/drawing/2014/main" id="{9B7B8D64-7C84-D61F-FE01-41F1BAE5BC60}"/>
+              </a:ext>
+            </a:extLst>
+          </p:cNvPr>
+          <p:cNvPicPr>
+            <a:picLocks noChangeAspect="1"/>
+          </p:cNvPicPr>
+          <p:nvPr/>
+        </p:nvPicPr>
+        <p:blipFill>
+          <a:blip r:embed="rId2"/>
+          <a:stretch>
+            <a:fillRect/>
+          </a:stretch>
+        </p:blipFill>
+        <p:spPr>
+          <a:xfrm>
+            <a:off x="82072" y="1436914"/>
+            <a:ext cx="6392167" cy="1571844"/>
+          </a:xfrm>
+          <a:prstGeom prst="rect">
+            <a:avLst/>
+          </a:prstGeom>
+        </p:spPr>
+      </p:pic>
+      <p:pic>
+        <p:nvPicPr>
+          <p:cNvPr id="7" name="Picture 6">
+            <a:extLst>
+              <a:ext uri="{FF2B5EF4-FFF2-40B4-BE49-F238E27FC236}">
+                <a16:creationId xmlns:a16="http://schemas.microsoft.com/office/drawing/2014/main" id="{37C8A6EF-9AE3-78B5-D106-7E10EF232B7F}"/>
+              </a:ext>
+            </a:extLst>
+          </p:cNvPr>
+          <p:cNvPicPr>
+            <a:picLocks noChangeAspect="1"/>
+          </p:cNvPicPr>
+          <p:nvPr/>
+        </p:nvPicPr>
+        <p:blipFill>
+          <a:blip r:embed="rId3"/>
+          <a:stretch>
+            <a:fillRect/>
+          </a:stretch>
+        </p:blipFill>
+        <p:spPr>
+          <a:xfrm>
+            <a:off x="6474238" y="0"/>
+            <a:ext cx="5635689" cy="6858000"/>
+          </a:xfrm>
+          <a:prstGeom prst="rect">
+            <a:avLst/>
+          </a:prstGeom>
+        </p:spPr>
+      </p:pic>
+    </p:spTree>
+    <p:extLst>
+      <p:ext uri="{BB962C8B-B14F-4D97-AF65-F5344CB8AC3E}">
+        <p14:creationId xmlns:p14="http://schemas.microsoft.com/office/powerpoint/2010/main" val="3006161335"/>
       </p:ext>
     </p:extLst>
   </p:cSld>
@@ -3640,10 +5658,6 @@
               <a:rPr lang="en-US" sz="4000" b="1" dirty="0"/>
               <a:t>K means Clustering Algorithm Explained With an Example Easiest And Quickest Way Ever</a:t>
             </a:r>
-            <a:r>
-              <a:rPr lang="en-US" dirty="0"/>
-              <a:t/>
-            </a:r>
             <a:br>
               <a:rPr lang="en-US" dirty="0"/>
             </a:br>
@@ -3731,20 +5745,159 @@
     </p:spTree>
     <p:extLst>
       <p:ext uri="{BB962C8B-B14F-4D97-AF65-F5344CB8AC3E}">
-        <p14:creationId xmlns="" xmlns:p14="http://schemas.microsoft.com/office/powerpoint/2010/main" val="1526193689"/>
+        <p14:creationId xmlns:p14="http://schemas.microsoft.com/office/powerpoint/2010/main" val="1526193689"/>
       </p:ext>
     </p:extLst>
   </p:cSld>
   <p:clrMapOvr>
     <a:masterClrMapping/>
   </p:clrMapOvr>
-  <p:timing>
-    <p:tnLst>
-      <p:par>
-        <p:cTn id="1" dur="indefinite" restart="never" nodeType="tmRoot"/>
-      </p:par>
-    </p:tnLst>
-  </p:timing>
+</p:sld>
+</file>
+
+<file path=ppt/slides/slide20.xml><?xml version="1.0" encoding="utf-8"?>
+<p:sld xmlns:a="http://schemas.openxmlformats.org/drawingml/2006/main" xmlns:r="http://schemas.openxmlformats.org/officeDocument/2006/relationships" xmlns:p="http://schemas.openxmlformats.org/presentationml/2006/main">
+  <p:cSld>
+    <p:spTree>
+      <p:nvGrpSpPr>
+        <p:cNvPr id="1" name="">
+          <a:extLst>
+            <a:ext uri="{FF2B5EF4-FFF2-40B4-BE49-F238E27FC236}">
+              <a16:creationId xmlns:a16="http://schemas.microsoft.com/office/drawing/2014/main" id="{5F48AE7D-3A0B-0BA6-45DB-C010AE71E128}"/>
+            </a:ext>
+          </a:extLst>
+        </p:cNvPr>
+        <p:cNvGrpSpPr/>
+        <p:nvPr/>
+      </p:nvGrpSpPr>
+      <p:grpSpPr>
+        <a:xfrm>
+          <a:off x="0" y="0"/>
+          <a:ext cx="0" cy="0"/>
+          <a:chOff x="0" y="0"/>
+          <a:chExt cx="0" cy="0"/>
+        </a:xfrm>
+      </p:grpSpPr>
+      <p:sp>
+        <p:nvSpPr>
+          <p:cNvPr id="2" name="Title 1">
+            <a:extLst>
+              <a:ext uri="{FF2B5EF4-FFF2-40B4-BE49-F238E27FC236}">
+                <a16:creationId xmlns:a16="http://schemas.microsoft.com/office/drawing/2014/main" id="{E9ED08C8-728A-6A57-9C84-327F97FEFE32}"/>
+              </a:ext>
+            </a:extLst>
+          </p:cNvPr>
+          <p:cNvSpPr>
+            <a:spLocks noGrp="1"/>
+          </p:cNvSpPr>
+          <p:nvPr>
+            <p:ph type="title"/>
+          </p:nvPr>
+        </p:nvSpPr>
+        <p:spPr/>
+        <p:txBody>
+          <a:bodyPr/>
+          <a:lstStyle/>
+          <a:p>
+            <a:endParaRPr lang="en-US"/>
+          </a:p>
+        </p:txBody>
+      </p:sp>
+      <p:sp>
+        <p:nvSpPr>
+          <p:cNvPr id="3" name="Content Placeholder 2">
+            <a:extLst>
+              <a:ext uri="{FF2B5EF4-FFF2-40B4-BE49-F238E27FC236}">
+                <a16:creationId xmlns:a16="http://schemas.microsoft.com/office/drawing/2014/main" id="{62B3C0A2-D0BA-0849-9AEF-C44292BEF7CC}"/>
+              </a:ext>
+            </a:extLst>
+          </p:cNvPr>
+          <p:cNvSpPr>
+            <a:spLocks noGrp="1"/>
+          </p:cNvSpPr>
+          <p:nvPr>
+            <p:ph idx="1"/>
+          </p:nvPr>
+        </p:nvSpPr>
+        <p:spPr/>
+        <p:txBody>
+          <a:bodyPr/>
+          <a:lstStyle/>
+          <a:p>
+            <a:endParaRPr lang="en-US"/>
+          </a:p>
+        </p:txBody>
+      </p:sp>
+      <p:pic>
+        <p:nvPicPr>
+          <p:cNvPr id="7" name="Picture 6">
+            <a:extLst>
+              <a:ext uri="{FF2B5EF4-FFF2-40B4-BE49-F238E27FC236}">
+                <a16:creationId xmlns:a16="http://schemas.microsoft.com/office/drawing/2014/main" id="{6335E965-DB62-32B7-7714-2FE6E6707721}"/>
+              </a:ext>
+            </a:extLst>
+          </p:cNvPr>
+          <p:cNvPicPr>
+            <a:picLocks noChangeAspect="1"/>
+          </p:cNvPicPr>
+          <p:nvPr/>
+        </p:nvPicPr>
+        <p:blipFill>
+          <a:blip r:embed="rId2"/>
+          <a:stretch>
+            <a:fillRect/>
+          </a:stretch>
+        </p:blipFill>
+        <p:spPr>
+          <a:xfrm>
+            <a:off x="0" y="0"/>
+            <a:ext cx="5635689" cy="6858000"/>
+          </a:xfrm>
+          <a:prstGeom prst="rect">
+            <a:avLst/>
+          </a:prstGeom>
+        </p:spPr>
+      </p:pic>
+      <p:pic>
+        <p:nvPicPr>
+          <p:cNvPr id="6" name="Picture 5">
+            <a:extLst>
+              <a:ext uri="{FF2B5EF4-FFF2-40B4-BE49-F238E27FC236}">
+                <a16:creationId xmlns:a16="http://schemas.microsoft.com/office/drawing/2014/main" id="{BA1BE692-B6F8-A9FB-3CFA-2DBD64D4059E}"/>
+              </a:ext>
+            </a:extLst>
+          </p:cNvPr>
+          <p:cNvPicPr>
+            <a:picLocks noChangeAspect="1"/>
+          </p:cNvPicPr>
+          <p:nvPr/>
+        </p:nvPicPr>
+        <p:blipFill>
+          <a:blip r:embed="rId3"/>
+          <a:stretch>
+            <a:fillRect/>
+          </a:stretch>
+        </p:blipFill>
+        <p:spPr>
+          <a:xfrm>
+            <a:off x="5635689" y="141173"/>
+            <a:ext cx="6556311" cy="6716827"/>
+          </a:xfrm>
+          <a:prstGeom prst="rect">
+            <a:avLst/>
+          </a:prstGeom>
+        </p:spPr>
+      </p:pic>
+    </p:spTree>
+    <p:extLst>
+      <p:ext uri="{BB962C8B-B14F-4D97-AF65-F5344CB8AC3E}">
+        <p14:creationId xmlns:p14="http://schemas.microsoft.com/office/powerpoint/2010/main" val="2897952952"/>
+      </p:ext>
+    </p:extLst>
+  </p:cSld>
+  <p:clrMapOvr>
+    <a:masterClrMapping/>
+  </p:clrMapOvr>
 </p:sld>
 </file>
 
@@ -3809,7 +5962,7 @@
     </p:spTree>
     <p:extLst>
       <p:ext uri="{BB962C8B-B14F-4D97-AF65-F5344CB8AC3E}">
-        <p14:creationId xmlns="" xmlns:p14="http://schemas.microsoft.com/office/powerpoint/2010/main" val="3214989462"/>
+        <p14:creationId xmlns:p14="http://schemas.microsoft.com/office/powerpoint/2010/main" val="3214989462"/>
       </p:ext>
     </p:extLst>
   </p:cSld>
@@ -3859,10 +6012,9 @@
           <a:lstStyle/>
           <a:p>
             <a:r>
-              <a:rPr lang="en-US" sz="4000" b="1" dirty="0" smtClean="0"/>
+              <a:rPr lang="en-US" sz="4000" b="1" dirty="0"/>
               <a:t>K-means clustering with k=3  (same previous example)</a:t>
             </a:r>
-            <a:endParaRPr lang="en-US" sz="4000" b="1" dirty="0"/>
           </a:p>
         </p:txBody>
       </p:sp>
@@ -3882,7 +6034,7 @@
           <a:lstStyle/>
           <a:p>
             <a:r>
-              <a:rPr lang="en-US" smtClean="0"/>
+              <a:rPr lang="en-US"/>
               <a:t>Data are</a:t>
             </a:r>
             <a:endParaRPr lang="en-US" dirty="0"/>
@@ -3911,7 +6063,7 @@
           <a:lstStyle/>
           <a:p>
             <a:r>
-              <a:rPr lang="en-US" dirty="0" smtClean="0">
+              <a:rPr lang="en-US" dirty="0">
                 <a:solidFill>
                   <a:srgbClr val="FF0000"/>
                 </a:solidFill>
@@ -3921,7 +6073,7 @@
           </a:p>
           <a:p>
             <a:r>
-              <a:rPr lang="en-US" dirty="0" smtClean="0">
+              <a:rPr lang="en-US" dirty="0">
                 <a:solidFill>
                   <a:srgbClr val="FF0000"/>
                 </a:solidFill>
@@ -3931,18 +6083,13 @@
           </a:p>
           <a:p>
             <a:r>
-              <a:rPr lang="en-US" dirty="0" smtClean="0">
+              <a:rPr lang="en-US" dirty="0">
                 <a:solidFill>
                   <a:srgbClr val="FF0000"/>
                 </a:solidFill>
               </a:rPr>
               <a:t>(180,67), (177,76)</a:t>
             </a:r>
-            <a:endParaRPr lang="en-US" dirty="0">
-              <a:solidFill>
-                <a:srgbClr val="FF0000"/>
-              </a:solidFill>
-            </a:endParaRPr>
           </a:p>
         </p:txBody>
       </p:sp>
@@ -3994,10 +6141,9 @@
           <a:lstStyle/>
           <a:p>
             <a:r>
-              <a:rPr lang="en-US" sz="4000" b="1" dirty="0" smtClean="0"/>
+              <a:rPr lang="en-US" sz="4000" b="1" dirty="0"/>
               <a:t>K-means clustering with k=3  (same previous example)</a:t>
             </a:r>
-            <a:endParaRPr lang="en-US" sz="4000" b="1" dirty="0"/>
           </a:p>
         </p:txBody>
       </p:sp>
@@ -4101,10 +6247,9 @@
           <a:lstStyle/>
           <a:p>
             <a:r>
-              <a:rPr lang="en-US" sz="4000" b="1" dirty="0" smtClean="0"/>
+              <a:rPr lang="en-US" sz="4000" b="1" dirty="0"/>
               <a:t>K-means clustering with k=3  (same previous example)</a:t>
             </a:r>
-            <a:endParaRPr lang="en-US" sz="4000" b="1" dirty="0"/>
           </a:p>
         </p:txBody>
       </p:sp>
@@ -4208,10 +6353,9 @@
           <a:lstStyle/>
           <a:p>
             <a:r>
-              <a:rPr lang="en-US" sz="4000" b="1" dirty="0" smtClean="0"/>
+              <a:rPr lang="en-US" sz="4000" b="1" dirty="0"/>
               <a:t>K-means clustering with k=3  (same previous example)</a:t>
             </a:r>
-            <a:endParaRPr lang="en-US" sz="4000" b="1" dirty="0"/>
           </a:p>
         </p:txBody>
       </p:sp>
@@ -4315,10 +6459,9 @@
           <a:lstStyle/>
           <a:p>
             <a:r>
-              <a:rPr lang="en-US" sz="4000" b="1" dirty="0" smtClean="0"/>
+              <a:rPr lang="en-US" sz="4000" b="1" dirty="0"/>
               <a:t>K-means clustering with k=3  (same previous example)</a:t>
             </a:r>
-            <a:endParaRPr lang="en-US" sz="4000" b="1" dirty="0"/>
           </a:p>
         </p:txBody>
       </p:sp>
@@ -4341,11 +6484,41 @@
             <a:tbl>
               <a:tblPr/>
               <a:tblGrid>
-                <a:gridCol w="1505694"/>
-                <a:gridCol w="1505694"/>
-                <a:gridCol w="1505694"/>
-                <a:gridCol w="1505694"/>
-                <a:gridCol w="1505694"/>
+                <a:gridCol w="1505694">
+                  <a:extLst>
+                    <a:ext uri="{9D8B030D-6E8A-4147-A177-3AD203B41FA5}">
+                      <a16:colId xmlns:a16="http://schemas.microsoft.com/office/drawing/2014/main" val="20000"/>
+                    </a:ext>
+                  </a:extLst>
+                </a:gridCol>
+                <a:gridCol w="1505694">
+                  <a:extLst>
+                    <a:ext uri="{9D8B030D-6E8A-4147-A177-3AD203B41FA5}">
+                      <a16:colId xmlns:a16="http://schemas.microsoft.com/office/drawing/2014/main" val="20001"/>
+                    </a:ext>
+                  </a:extLst>
+                </a:gridCol>
+                <a:gridCol w="1505694">
+                  <a:extLst>
+                    <a:ext uri="{9D8B030D-6E8A-4147-A177-3AD203B41FA5}">
+                      <a16:colId xmlns:a16="http://schemas.microsoft.com/office/drawing/2014/main" val="20002"/>
+                    </a:ext>
+                  </a:extLst>
+                </a:gridCol>
+                <a:gridCol w="1505694">
+                  <a:extLst>
+                    <a:ext uri="{9D8B030D-6E8A-4147-A177-3AD203B41FA5}">
+                      <a16:colId xmlns:a16="http://schemas.microsoft.com/office/drawing/2014/main" val="20003"/>
+                    </a:ext>
+                  </a:extLst>
+                </a:gridCol>
+                <a:gridCol w="1505694">
+                  <a:extLst>
+                    <a:ext uri="{9D8B030D-6E8A-4147-A177-3AD203B41FA5}">
+                      <a16:colId xmlns:a16="http://schemas.microsoft.com/office/drawing/2014/main" val="20004"/>
+                    </a:ext>
+                  </a:extLst>
+                </a:gridCol>
               </a:tblGrid>
               <a:tr h="349486">
                 <a:tc>
@@ -4713,6 +6886,11 @@
                     </a:lnB>
                   </a:tcPr>
                 </a:tc>
+                <a:extLst>
+                  <a:ext uri="{0D108BD9-81ED-4DB2-BD59-A6C34878D82A}">
+                    <a16:rowId xmlns:a16="http://schemas.microsoft.com/office/drawing/2014/main" val="10000"/>
+                  </a:ext>
+                </a:extLst>
               </a:tr>
               <a:tr h="333488">
                 <a:tc>
@@ -5091,6 +7269,11 @@
                     </a:lnB>
                   </a:tcPr>
                 </a:tc>
+                <a:extLst>
+                  <a:ext uri="{0D108BD9-81ED-4DB2-BD59-A6C34878D82A}">
+                    <a16:rowId xmlns:a16="http://schemas.microsoft.com/office/drawing/2014/main" val="10001"/>
+                  </a:ext>
+                </a:extLst>
               </a:tr>
               <a:tr h="333488">
                 <a:tc>
@@ -5469,6 +7652,11 @@
                     </a:lnB>
                   </a:tcPr>
                 </a:tc>
+                <a:extLst>
+                  <a:ext uri="{0D108BD9-81ED-4DB2-BD59-A6C34878D82A}">
+                    <a16:rowId xmlns:a16="http://schemas.microsoft.com/office/drawing/2014/main" val="10002"/>
+                  </a:ext>
+                </a:extLst>
               </a:tr>
               <a:tr h="333488">
                 <a:tc>
@@ -5847,6 +8035,11 @@
                     </a:lnB>
                   </a:tcPr>
                 </a:tc>
+                <a:extLst>
+                  <a:ext uri="{0D108BD9-81ED-4DB2-BD59-A6C34878D82A}">
+                    <a16:rowId xmlns:a16="http://schemas.microsoft.com/office/drawing/2014/main" val="10003"/>
+                  </a:ext>
+                </a:extLst>
               </a:tr>
               <a:tr h="333488">
                 <a:tc>
@@ -6225,6 +8418,11 @@
                     </a:lnB>
                   </a:tcPr>
                 </a:tc>
+                <a:extLst>
+                  <a:ext uri="{0D108BD9-81ED-4DB2-BD59-A6C34878D82A}">
+                    <a16:rowId xmlns:a16="http://schemas.microsoft.com/office/drawing/2014/main" val="10004"/>
+                  </a:ext>
+                </a:extLst>
               </a:tr>
               <a:tr h="333488">
                 <a:tc>
@@ -6603,6 +8801,11 @@
                     </a:lnB>
                   </a:tcPr>
                 </a:tc>
+                <a:extLst>
+                  <a:ext uri="{0D108BD9-81ED-4DB2-BD59-A6C34878D82A}">
+                    <a16:rowId xmlns:a16="http://schemas.microsoft.com/office/drawing/2014/main" val="10005"/>
+                  </a:ext>
+                </a:extLst>
               </a:tr>
               <a:tr h="333488">
                 <a:tc>
@@ -6981,6 +9184,11 @@
                     </a:lnB>
                   </a:tcPr>
                 </a:tc>
+                <a:extLst>
+                  <a:ext uri="{0D108BD9-81ED-4DB2-BD59-A6C34878D82A}">
+                    <a16:rowId xmlns:a16="http://schemas.microsoft.com/office/drawing/2014/main" val="10006"/>
+                  </a:ext>
+                </a:extLst>
               </a:tr>
               <a:tr h="333488">
                 <a:tc>
@@ -7359,6 +9567,11 @@
                     </a:lnB>
                   </a:tcPr>
                 </a:tc>
+                <a:extLst>
+                  <a:ext uri="{0D108BD9-81ED-4DB2-BD59-A6C34878D82A}">
+                    <a16:rowId xmlns:a16="http://schemas.microsoft.com/office/drawing/2014/main" val="10007"/>
+                  </a:ext>
+                </a:extLst>
               </a:tr>
               <a:tr h="333488">
                 <a:tc>
@@ -7737,6 +9950,11 @@
                     </a:lnB>
                   </a:tcPr>
                 </a:tc>
+                <a:extLst>
+                  <a:ext uri="{0D108BD9-81ED-4DB2-BD59-A6C34878D82A}">
+                    <a16:rowId xmlns:a16="http://schemas.microsoft.com/office/drawing/2014/main" val="10008"/>
+                  </a:ext>
+                </a:extLst>
               </a:tr>
               <a:tr h="333488">
                 <a:tc>
@@ -8115,6 +10333,11 @@
                     </a:lnB>
                   </a:tcPr>
                 </a:tc>
+                <a:extLst>
+                  <a:ext uri="{0D108BD9-81ED-4DB2-BD59-A6C34878D82A}">
+                    <a16:rowId xmlns:a16="http://schemas.microsoft.com/office/drawing/2014/main" val="10009"/>
+                  </a:ext>
+                </a:extLst>
               </a:tr>
               <a:tr h="333488">
                 <a:tc>
@@ -8493,6 +10716,11 @@
                     </a:lnB>
                   </a:tcPr>
                 </a:tc>
+                <a:extLst>
+                  <a:ext uri="{0D108BD9-81ED-4DB2-BD59-A6C34878D82A}">
+                    <a16:rowId xmlns:a16="http://schemas.microsoft.com/office/drawing/2014/main" val="10010"/>
+                  </a:ext>
+                </a:extLst>
               </a:tr>
               <a:tr h="333488">
                 <a:tc>
@@ -8871,6 +11099,11 @@
                     </a:lnB>
                   </a:tcPr>
                 </a:tc>
+                <a:extLst>
+                  <a:ext uri="{0D108BD9-81ED-4DB2-BD59-A6C34878D82A}">
+                    <a16:rowId xmlns:a16="http://schemas.microsoft.com/office/drawing/2014/main" val="10011"/>
+                  </a:ext>
+                </a:extLst>
               </a:tr>
               <a:tr h="333488">
                 <a:tc>
@@ -9249,6 +11482,11 @@
                     </a:lnB>
                   </a:tcPr>
                 </a:tc>
+                <a:extLst>
+                  <a:ext uri="{0D108BD9-81ED-4DB2-BD59-A6C34878D82A}">
+                    <a16:rowId xmlns:a16="http://schemas.microsoft.com/office/drawing/2014/main" val="10012"/>
+                  </a:ext>
+                </a:extLst>
               </a:tr>
             </a:tbl>
           </a:graphicData>
@@ -9276,14 +11514,13 @@
           <a:lstStyle/>
           <a:p>
             <a:r>
-              <a:rPr lang="en-US" sz="2400" b="1" dirty="0" smtClean="0"/>
+              <a:rPr lang="en-US" sz="2400" b="1" dirty="0"/>
               <a:t>Distance Table (Approximated</a:t>
             </a:r>
             <a:r>
-              <a:rPr lang="en-US" dirty="0" smtClean="0"/>
+              <a:rPr lang="en-US" dirty="0"/>
               <a:t>)</a:t>
             </a:r>
-            <a:endParaRPr lang="en-US" dirty="0"/>
           </a:p>
         </p:txBody>
       </p:sp>
@@ -9361,7 +11598,7 @@
           <a:lstStyle/>
           <a:p>
             <a:r>
-              <a:rPr lang="en-US" b="1" dirty="0" smtClean="0"/>
+              <a:rPr lang="en-US" b="1" dirty="0"/>
               <a:t>K-means clustering with k=3  (same previous example)</a:t>
             </a:r>
             <a:endParaRPr lang="en-US" dirty="0"/>
@@ -9384,41 +11621,41 @@
           <a:lstStyle/>
           <a:p>
             <a:r>
-              <a:rPr lang="en-US" b="1" dirty="0" smtClean="0"/>
+              <a:rPr lang="en-US" b="1" dirty="0"/>
               <a:t>Step 4: Reassign Points</a:t>
             </a:r>
           </a:p>
           <a:p>
             <a:pPr lvl="1"/>
             <a:r>
-              <a:rPr lang="en-US" dirty="0" smtClean="0"/>
+              <a:rPr lang="en-US" dirty="0"/>
               <a:t>Repeat distance calculation with </a:t>
             </a:r>
             <a:r>
-              <a:rPr lang="en-US" b="1" dirty="0" smtClean="0"/>
+              <a:rPr lang="en-US" b="1" dirty="0"/>
               <a:t>updated </a:t>
             </a:r>
             <a:r>
-              <a:rPr lang="en-US" b="1" dirty="0" err="1" smtClean="0"/>
+              <a:rPr lang="en-US" b="1" dirty="0" err="1"/>
               <a:t>centroids</a:t>
             </a:r>
             <a:r>
-              <a:rPr lang="en-US" dirty="0" smtClean="0"/>
+              <a:rPr lang="en-US" dirty="0"/>
               <a:t> (169,58), (181.38,71.63), and (181.5,86).</a:t>
             </a:r>
             <a:br>
-              <a:rPr lang="en-US" dirty="0" smtClean="0"/>
+              <a:rPr lang="en-US" dirty="0"/>
             </a:br>
-            <a:endParaRPr lang="en-US" dirty="0" smtClean="0"/>
+            <a:endParaRPr lang="en-US" dirty="0"/>
           </a:p>
           <a:p>
             <a:pPr lvl="1"/>
             <a:r>
-              <a:rPr lang="en-US" dirty="0" smtClean="0"/>
+              <a:rPr lang="en-US" dirty="0"/>
               <a:t>Most points </a:t>
             </a:r>
             <a:r>
-              <a:rPr lang="en-US" dirty="0" smtClean="0">
+              <a:rPr lang="en-US" dirty="0">
                 <a:solidFill>
                   <a:srgbClr val="FF0000"/>
                 </a:solidFill>
@@ -9426,15 +11663,15 @@
               <a:t>will likely stay in the same cluster</a:t>
             </a:r>
             <a:r>
-              <a:rPr lang="en-US" dirty="0" smtClean="0"/>
+              <a:rPr lang="en-US" dirty="0"/>
               <a:t>—repeat until </a:t>
             </a:r>
             <a:r>
-              <a:rPr lang="en-US" dirty="0" err="1" smtClean="0"/>
+              <a:rPr lang="en-US" dirty="0" err="1"/>
               <a:t>centroids</a:t>
             </a:r>
             <a:r>
-              <a:rPr lang="en-US" dirty="0" smtClean="0"/>
+              <a:rPr lang="en-US" dirty="0"/>
               <a:t> don't change significantly.</a:t>
             </a:r>
           </a:p>
@@ -9706,7 +11943,7 @@
   <a:extraClrSchemeLst/>
   <a:extLst>
     <a:ext uri="{05A4C25C-085E-4340-85A3-A5531E510DB2}">
-      <thm15:themeFamily xmlns="" xmlns:thm15="http://schemas.microsoft.com/office/thememl/2012/main" name="Office Theme" id="{62F939B6-93AF-4DB8-9C6B-D6C7DFDC589F}" vid="{4A3C46E8-61CC-4603-A589-7422A47A8E4A}"/>
+      <thm15:themeFamily xmlns:thm15="http://schemas.microsoft.com/office/thememl/2012/main" name="Office Theme" id="{62F939B6-93AF-4DB8-9C6B-D6C7DFDC589F}" vid="{4A3C46E8-61CC-4603-A589-7422A47A8E4A}"/>
     </a:ext>
   </a:extLst>
 </a:theme>

</xml_diff>